<commit_message>
2fixed CORS configuration to allow credentials from local frontend
</commit_message>
<xml_diff>
--- a/Server Backend/Assignment/CMP5387_ProductDemo_Template.pptx
+++ b/Server Backend/Assignment/CMP5387_ProductDemo_Template.pptx
@@ -154,9 +154,6 @@
         </p14:section>
       </p14:sectionLst>
     </p:ext>
-    <p:ext uri="{EFAFB233-063F-42B5-8137-9DF3F51BA10A}">
-      <p15:sldGuideLst xmlns:p15="http://schemas.microsoft.com/office/powerpoint/2012/main"/>
-    </p:ext>
   </p:extLst>
 </p:presentation>
 </file>
@@ -190,8 +187,10 @@
 <file path=ppt/revisionInfo.xml><?xml version="1.0" encoding="utf-8"?>
 <p1510:revInfo xmlns:a="http://schemas.openxmlformats.org/drawingml/2006/main" xmlns:r="http://schemas.openxmlformats.org/officeDocument/2006/relationships" xmlns:p1510="http://schemas.microsoft.com/office/powerpoint/2015/10/main">
   <p1510:revLst>
-    <p1510:client id="{3621F125-8D30-569F-5FED-6D29C84ECEDE}" v="368" dt="2026-01-22T13:23:46.283"/>
-    <p1510:client id="{E7361B5A-EB23-0794-CE6A-15FBCF7DDB4B}" v="797" dt="2026-01-22T11:28:16.492"/>
+    <p1510:client id="{3621F125-8D30-569F-5FED-6D29C84ECEDE}" v="375" dt="2026-01-22T15:58:47.427"/>
+    <p1510:client id="{3A1139BF-7EE5-BE45-1471-B0A1FC9D3AED}" v="56" dt="2026-01-22T15:36:34.911"/>
+    <p1510:client id="{9BD5A22C-6581-C90B-83EB-92BED6B2B160}" v="105" dt="2026-01-22T14:54:36.164"/>
+    <p1510:client id="{E7361B5A-EB23-0794-CE6A-15FBCF7DDB4B}" v="807" dt="2026-01-22T15:52:32.987"/>
   </p1510:revLst>
 </p1510:revInfo>
 </file>
@@ -199,9 +198,184 @@
 <file path=ppt/changesInfos/changesInfo1.xml><?xml version="1.0" encoding="utf-8"?>
 <pc:chgInfo xmlns:a="http://schemas.openxmlformats.org/drawingml/2006/main" xmlns:r="http://schemas.openxmlformats.org/officeDocument/2006/relationships" xmlns:ac="http://schemas.microsoft.com/office/drawing/2013/main/command" xmlns:pc="http://schemas.microsoft.com/office/powerpoint/2013/main/command">
   <pc:docChgLst>
+    <pc:chgData name="Abraham Kubrom" userId="S::abraham.kubrom@mail.bcu.ac.uk::3bb85157-d1ec-461b-a19b-dd3f0a57a866" providerId="AD" clId="Web-{3A1139BF-7EE5-BE45-1471-B0A1FC9D3AED}"/>
+    <pc:docChg chg="modSld">
+      <pc:chgData name="Abraham Kubrom" userId="S::abraham.kubrom@mail.bcu.ac.uk::3bb85157-d1ec-461b-a19b-dd3f0a57a866" providerId="AD" clId="Web-{3A1139BF-7EE5-BE45-1471-B0A1FC9D3AED}" dt="2026-01-22T15:36:33.427" v="36" actId="20577"/>
+      <pc:docMkLst>
+        <pc:docMk/>
+      </pc:docMkLst>
+      <pc:sldChg chg="addSp delSp modSp">
+        <pc:chgData name="Abraham Kubrom" userId="S::abraham.kubrom@mail.bcu.ac.uk::3bb85157-d1ec-461b-a19b-dd3f0a57a866" providerId="AD" clId="Web-{3A1139BF-7EE5-BE45-1471-B0A1FC9D3AED}" dt="2026-01-22T15:36:33.427" v="36" actId="20577"/>
+        <pc:sldMkLst>
+          <pc:docMk/>
+          <pc:sldMk cId="1355005947" sldId="641"/>
+        </pc:sldMkLst>
+        <pc:spChg chg="add del">
+          <ac:chgData name="Abraham Kubrom" userId="S::abraham.kubrom@mail.bcu.ac.uk::3bb85157-d1ec-461b-a19b-dd3f0a57a866" providerId="AD" clId="Web-{3A1139BF-7EE5-BE45-1471-B0A1FC9D3AED}" dt="2026-01-22T15:35:12.707" v="9"/>
+          <ac:spMkLst>
+            <pc:docMk/>
+            <pc:sldMk cId="1355005947" sldId="641"/>
+            <ac:spMk id="6" creationId="{EF489ABE-A7A3-FB09-1859-C1A97AF39950}"/>
+          </ac:spMkLst>
+        </pc:spChg>
+        <pc:spChg chg="add mod">
+          <ac:chgData name="Abraham Kubrom" userId="S::abraham.kubrom@mail.bcu.ac.uk::3bb85157-d1ec-461b-a19b-dd3f0a57a866" providerId="AD" clId="Web-{3A1139BF-7EE5-BE45-1471-B0A1FC9D3AED}" dt="2026-01-22T15:36:26.286" v="23" actId="20577"/>
+          <ac:spMkLst>
+            <pc:docMk/>
+            <pc:sldMk cId="1355005947" sldId="641"/>
+            <ac:spMk id="7" creationId="{B2D8061A-7D04-0CCE-BFF4-2FDC9C3D156F}"/>
+          </ac:spMkLst>
+        </pc:spChg>
+        <pc:spChg chg="del mod">
+          <ac:chgData name="Abraham Kubrom" userId="S::abraham.kubrom@mail.bcu.ac.uk::3bb85157-d1ec-461b-a19b-dd3f0a57a866" providerId="AD" clId="Web-{3A1139BF-7EE5-BE45-1471-B0A1FC9D3AED}" dt="2026-01-22T15:27:51.995" v="4"/>
+          <ac:spMkLst>
+            <pc:docMk/>
+            <pc:sldMk cId="1355005947" sldId="641"/>
+            <ac:spMk id="8" creationId="{FF77C238-3A1B-3996-B88D-F58C579FDE8F}"/>
+          </ac:spMkLst>
+        </pc:spChg>
+        <pc:spChg chg="mod">
+          <ac:chgData name="Abraham Kubrom" userId="S::abraham.kubrom@mail.bcu.ac.uk::3bb85157-d1ec-461b-a19b-dd3f0a57a866" providerId="AD" clId="Web-{3A1139BF-7EE5-BE45-1471-B0A1FC9D3AED}" dt="2026-01-22T15:36:33.427" v="36" actId="20577"/>
+          <ac:spMkLst>
+            <pc:docMk/>
+            <pc:sldMk cId="1355005947" sldId="641"/>
+            <ac:spMk id="12" creationId="{6FD7934D-0CA2-6EDD-4386-1967392E1816}"/>
+          </ac:spMkLst>
+        </pc:spChg>
+        <pc:picChg chg="mod">
+          <ac:chgData name="Abraham Kubrom" userId="S::abraham.kubrom@mail.bcu.ac.uk::3bb85157-d1ec-461b-a19b-dd3f0a57a866" providerId="AD" clId="Web-{3A1139BF-7EE5-BE45-1471-B0A1FC9D3AED}" dt="2026-01-22T15:28:06.308" v="7" actId="1076"/>
+          <ac:picMkLst>
+            <pc:docMk/>
+            <pc:sldMk cId="1355005947" sldId="641"/>
+            <ac:picMk id="3" creationId="{3897E974-C7F8-C54E-A93E-009ADC7E2359}"/>
+          </ac:picMkLst>
+        </pc:picChg>
+      </pc:sldChg>
+    </pc:docChg>
+  </pc:docChgLst>
+  <pc:docChgLst>
+    <pc:chgData name="Abraham Kubrom" userId="S::abraham.kubrom@mail.bcu.ac.uk::3bb85157-d1ec-461b-a19b-dd3f0a57a866" providerId="AD" clId="Web-{9BD5A22C-6581-C90B-83EB-92BED6B2B160}"/>
+    <pc:docChg chg="modSld">
+      <pc:chgData name="Abraham Kubrom" userId="S::abraham.kubrom@mail.bcu.ac.uk::3bb85157-d1ec-461b-a19b-dd3f0a57a866" providerId="AD" clId="Web-{9BD5A22C-6581-C90B-83EB-92BED6B2B160}" dt="2026-01-22T14:54:36.164" v="76" actId="1076"/>
+      <pc:docMkLst>
+        <pc:docMk/>
+      </pc:docMkLst>
+      <pc:sldChg chg="addSp delSp modSp">
+        <pc:chgData name="Abraham Kubrom" userId="S::abraham.kubrom@mail.bcu.ac.uk::3bb85157-d1ec-461b-a19b-dd3f0a57a866" providerId="AD" clId="Web-{9BD5A22C-6581-C90B-83EB-92BED6B2B160}" dt="2026-01-22T14:54:36.164" v="76" actId="1076"/>
+        <pc:sldMkLst>
+          <pc:docMk/>
+          <pc:sldMk cId="1355005947" sldId="641"/>
+        </pc:sldMkLst>
+        <pc:spChg chg="del mod">
+          <ac:chgData name="Abraham Kubrom" userId="S::abraham.kubrom@mail.bcu.ac.uk::3bb85157-d1ec-461b-a19b-dd3f0a57a866" providerId="AD" clId="Web-{9BD5A22C-6581-C90B-83EB-92BED6B2B160}" dt="2026-01-22T14:54:14.632" v="73"/>
+          <ac:spMkLst>
+            <pc:docMk/>
+            <pc:sldMk cId="1355005947" sldId="641"/>
+            <ac:spMk id="6" creationId="{80DAC7C5-DDE2-5FBC-4D1F-608903D10721}"/>
+          </ac:spMkLst>
+        </pc:spChg>
+        <pc:spChg chg="add mod">
+          <ac:chgData name="Abraham Kubrom" userId="S::abraham.kubrom@mail.bcu.ac.uk::3bb85157-d1ec-461b-a19b-dd3f0a57a866" providerId="AD" clId="Web-{9BD5A22C-6581-C90B-83EB-92BED6B2B160}" dt="2026-01-22T14:54:26.820" v="75" actId="14100"/>
+          <ac:spMkLst>
+            <pc:docMk/>
+            <pc:sldMk cId="1355005947" sldId="641"/>
+            <ac:spMk id="8" creationId="{FF77C238-3A1B-3996-B88D-F58C579FDE8F}"/>
+          </ac:spMkLst>
+        </pc:spChg>
+        <pc:picChg chg="add mod">
+          <ac:chgData name="Abraham Kubrom" userId="S::abraham.kubrom@mail.bcu.ac.uk::3bb85157-d1ec-461b-a19b-dd3f0a57a866" providerId="AD" clId="Web-{9BD5A22C-6581-C90B-83EB-92BED6B2B160}" dt="2026-01-22T14:54:36.164" v="76" actId="1076"/>
+          <ac:picMkLst>
+            <pc:docMk/>
+            <pc:sldMk cId="1355005947" sldId="641"/>
+            <ac:picMk id="3" creationId="{3897E974-C7F8-C54E-A93E-009ADC7E2359}"/>
+          </ac:picMkLst>
+        </pc:picChg>
+        <pc:picChg chg="del">
+          <ac:chgData name="Abraham Kubrom" userId="S::abraham.kubrom@mail.bcu.ac.uk::3bb85157-d1ec-461b-a19b-dd3f0a57a866" providerId="AD" clId="Web-{9BD5A22C-6581-C90B-83EB-92BED6B2B160}" dt="2026-01-22T14:53:25.225" v="63"/>
+          <ac:picMkLst>
+            <pc:docMk/>
+            <pc:sldMk cId="1355005947" sldId="641"/>
+            <ac:picMk id="2050" creationId="{5E51E38A-E7B1-5FDA-E9F3-DF53D3CA2316}"/>
+          </ac:picMkLst>
+        </pc:picChg>
+      </pc:sldChg>
+      <pc:sldChg chg="addSp delSp modSp">
+        <pc:chgData name="Abraham Kubrom" userId="S::abraham.kubrom@mail.bcu.ac.uk::3bb85157-d1ec-461b-a19b-dd3f0a57a866" providerId="AD" clId="Web-{9BD5A22C-6581-C90B-83EB-92BED6B2B160}" dt="2026-01-22T14:27:04.943" v="60" actId="20577"/>
+        <pc:sldMkLst>
+          <pc:docMk/>
+          <pc:sldMk cId="2373802056" sldId="650"/>
+        </pc:sldMkLst>
+        <pc:spChg chg="mod">
+          <ac:chgData name="Abraham Kubrom" userId="S::abraham.kubrom@mail.bcu.ac.uk::3bb85157-d1ec-461b-a19b-dd3f0a57a866" providerId="AD" clId="Web-{9BD5A22C-6581-C90B-83EB-92BED6B2B160}" dt="2026-01-22T14:10:43.536" v="9" actId="20577"/>
+          <ac:spMkLst>
+            <pc:docMk/>
+            <pc:sldMk cId="2373802056" sldId="650"/>
+            <ac:spMk id="4" creationId="{27ECB15D-6257-CEBD-5A41-BA7961E42C48}"/>
+          </ac:spMkLst>
+        </pc:spChg>
+        <pc:spChg chg="mod">
+          <ac:chgData name="Abraham Kubrom" userId="S::abraham.kubrom@mail.bcu.ac.uk::3bb85157-d1ec-461b-a19b-dd3f0a57a866" providerId="AD" clId="Web-{9BD5A22C-6581-C90B-83EB-92BED6B2B160}" dt="2026-01-22T14:25:49.034" v="36" actId="20577"/>
+          <ac:spMkLst>
+            <pc:docMk/>
+            <pc:sldMk cId="2373802056" sldId="650"/>
+            <ac:spMk id="9" creationId="{F6754AD4-2AA1-CE5F-9915-41C208AF4F1C}"/>
+          </ac:spMkLst>
+        </pc:spChg>
+        <pc:spChg chg="add del mod">
+          <ac:chgData name="Abraham Kubrom" userId="S::abraham.kubrom@mail.bcu.ac.uk::3bb85157-d1ec-461b-a19b-dd3f0a57a866" providerId="AD" clId="Web-{9BD5A22C-6581-C90B-83EB-92BED6B2B160}" dt="2026-01-22T14:23:40.984" v="27"/>
+          <ac:spMkLst>
+            <pc:docMk/>
+            <pc:sldMk cId="2373802056" sldId="650"/>
+            <ac:spMk id="10" creationId="{976CBBF9-2C26-1D21-502C-987A9D96D9E3}"/>
+          </ac:spMkLst>
+        </pc:spChg>
+        <pc:spChg chg="add mod">
+          <ac:chgData name="Abraham Kubrom" userId="S::abraham.kubrom@mail.bcu.ac.uk::3bb85157-d1ec-461b-a19b-dd3f0a57a866" providerId="AD" clId="Web-{9BD5A22C-6581-C90B-83EB-92BED6B2B160}" dt="2026-01-22T14:27:04.943" v="60" actId="20577"/>
+          <ac:spMkLst>
+            <pc:docMk/>
+            <pc:sldMk cId="2373802056" sldId="650"/>
+            <ac:spMk id="13" creationId="{688008E0-DB2D-0F1C-D927-7599BF2F98E4}"/>
+          </ac:spMkLst>
+        </pc:spChg>
+        <pc:picChg chg="add del mod">
+          <ac:chgData name="Abraham Kubrom" userId="S::abraham.kubrom@mail.bcu.ac.uk::3bb85157-d1ec-461b-a19b-dd3f0a57a866" providerId="AD" clId="Web-{9BD5A22C-6581-C90B-83EB-92BED6B2B160}" dt="2026-01-22T14:22:16.511" v="24"/>
+          <ac:picMkLst>
+            <pc:docMk/>
+            <pc:sldMk cId="2373802056" sldId="650"/>
+            <ac:picMk id="3" creationId="{D20BEEB3-9F21-FE9C-3ADD-8AE78DC547AE}"/>
+          </ac:picMkLst>
+        </pc:picChg>
+        <pc:picChg chg="del">
+          <ac:chgData name="Abraham Kubrom" userId="S::abraham.kubrom@mail.bcu.ac.uk::3bb85157-d1ec-461b-a19b-dd3f0a57a866" providerId="AD" clId="Web-{9BD5A22C-6581-C90B-83EB-92BED6B2B160}" dt="2026-01-22T14:19:50.186" v="11"/>
+          <ac:picMkLst>
+            <pc:docMk/>
+            <pc:sldMk cId="2373802056" sldId="650"/>
+            <ac:picMk id="6" creationId="{AA6D55E1-219E-318E-E15F-FB765DF2AFDC}"/>
+          </ac:picMkLst>
+        </pc:picChg>
+        <pc:picChg chg="add del mod ord">
+          <ac:chgData name="Abraham Kubrom" userId="S::abraham.kubrom@mail.bcu.ac.uk::3bb85157-d1ec-461b-a19b-dd3f0a57a866" providerId="AD" clId="Web-{9BD5A22C-6581-C90B-83EB-92BED6B2B160}" dt="2026-01-22T14:22:46.497" v="26"/>
+          <ac:picMkLst>
+            <pc:docMk/>
+            <pc:sldMk cId="2373802056" sldId="650"/>
+            <ac:picMk id="11" creationId="{98C95E8F-2A36-0ED1-282D-2CB9DE1F8AD8}"/>
+          </ac:picMkLst>
+        </pc:picChg>
+        <pc:picChg chg="add mod ord">
+          <ac:chgData name="Abraham Kubrom" userId="S::abraham.kubrom@mail.bcu.ac.uk::3bb85157-d1ec-461b-a19b-dd3f0a57a866" providerId="AD" clId="Web-{9BD5A22C-6581-C90B-83EB-92BED6B2B160}" dt="2026-01-22T14:25:37.252" v="32" actId="14100"/>
+          <ac:picMkLst>
+            <pc:docMk/>
+            <pc:sldMk cId="2373802056" sldId="650"/>
+            <ac:picMk id="12" creationId="{B78A246C-7B40-6767-EE88-50FE19B92103}"/>
+          </ac:picMkLst>
+        </pc:picChg>
+      </pc:sldChg>
+    </pc:docChg>
+  </pc:docChgLst>
+  <pc:docChgLst>
     <pc:chgData name="Alex Rush" userId="S::alex.rush@mail.bcu.ac.uk::3553fc2e-875d-4b8e-9341-9209134c3454" providerId="AD" clId="Web-{E7361B5A-EB23-0794-CE6A-15FBCF7DDB4B}"/>
     <pc:docChg chg="modSld sldOrd">
-      <pc:chgData name="Alex Rush" userId="S::alex.rush@mail.bcu.ac.uk::3553fc2e-875d-4b8e-9341-9209134c3454" providerId="AD" clId="Web-{E7361B5A-EB23-0794-CE6A-15FBCF7DDB4B}" dt="2026-01-22T11:28:16.179" v="568" actId="1076"/>
+      <pc:chgData name="Alex Rush" userId="S::alex.rush@mail.bcu.ac.uk::3553fc2e-875d-4b8e-9341-9209134c3454" providerId="AD" clId="Web-{E7361B5A-EB23-0794-CE6A-15FBCF7DDB4B}" dt="2026-01-22T15:52:32.987" v="572"/>
       <pc:docMkLst>
         <pc:docMk/>
       </pc:docMkLst>
@@ -320,13 +494,13 @@
         </pc:spChg>
       </pc:sldChg>
       <pc:sldChg chg="modSp">
-        <pc:chgData name="Alex Rush" userId="S::alex.rush@mail.bcu.ac.uk::3553fc2e-875d-4b8e-9341-9209134c3454" providerId="AD" clId="Web-{E7361B5A-EB23-0794-CE6A-15FBCF7DDB4B}" dt="2026-01-22T11:06:18.166" v="112" actId="14100"/>
+        <pc:chgData name="Alex Rush" userId="S::alex.rush@mail.bcu.ac.uk::3553fc2e-875d-4b8e-9341-9209134c3454" providerId="AD" clId="Web-{E7361B5A-EB23-0794-CE6A-15FBCF7DDB4B}" dt="2026-01-22T15:52:21.174" v="571" actId="20577"/>
         <pc:sldMkLst>
           <pc:docMk/>
           <pc:sldMk cId="2483116790" sldId="639"/>
         </pc:sldMkLst>
         <pc:spChg chg="mod">
-          <ac:chgData name="Alex Rush" userId="S::alex.rush@mail.bcu.ac.uk::3553fc2e-875d-4b8e-9341-9209134c3454" providerId="AD" clId="Web-{E7361B5A-EB23-0794-CE6A-15FBCF7DDB4B}" dt="2026-01-22T11:04:02.633" v="26" actId="20577"/>
+          <ac:chgData name="Alex Rush" userId="S::alex.rush@mail.bcu.ac.uk::3553fc2e-875d-4b8e-9341-9209134c3454" providerId="AD" clId="Web-{E7361B5A-EB23-0794-CE6A-15FBCF7DDB4B}" dt="2026-01-22T15:52:21.174" v="571" actId="20577"/>
           <ac:spMkLst>
             <pc:docMk/>
             <pc:sldMk cId="2483116790" sldId="639"/>
@@ -350,6 +524,21 @@
           </ac:picMkLst>
         </pc:picChg>
       </pc:sldChg>
+      <pc:sldChg chg="modSp ord">
+        <pc:chgData name="Alex Rush" userId="S::alex.rush@mail.bcu.ac.uk::3553fc2e-875d-4b8e-9341-9209134c3454" providerId="AD" clId="Web-{E7361B5A-EB23-0794-CE6A-15FBCF7DDB4B}" dt="2026-01-22T15:52:32.987" v="572"/>
+        <pc:sldMkLst>
+          <pc:docMk/>
+          <pc:sldMk cId="921905828" sldId="649"/>
+        </pc:sldMkLst>
+        <pc:spChg chg="mod">
+          <ac:chgData name="Alex Rush" userId="S::alex.rush@mail.bcu.ac.uk::3553fc2e-875d-4b8e-9341-9209134c3454" providerId="AD" clId="Web-{E7361B5A-EB23-0794-CE6A-15FBCF7DDB4B}" dt="2026-01-22T15:51:50.626" v="569" actId="20577"/>
+          <ac:spMkLst>
+            <pc:docMk/>
+            <pc:sldMk cId="921905828" sldId="649"/>
+            <ac:spMk id="12" creationId="{B79160D6-1290-2C0B-A289-B8DA43D00581}"/>
+          </ac:spMkLst>
+        </pc:spChg>
+      </pc:sldChg>
       <pc:sldChg chg="ord">
         <pc:chgData name="Alex Rush" userId="S::alex.rush@mail.bcu.ac.uk::3553fc2e-875d-4b8e-9341-9209134c3454" providerId="AD" clId="Web-{E7361B5A-EB23-0794-CE6A-15FBCF7DDB4B}" dt="2026-01-22T11:07:16.729" v="115"/>
         <pc:sldMkLst>
@@ -357,12 +546,20 @@
           <pc:sldMk cId="1499978597" sldId="651"/>
         </pc:sldMkLst>
       </pc:sldChg>
-      <pc:sldChg chg="ord">
-        <pc:chgData name="Alex Rush" userId="S::alex.rush@mail.bcu.ac.uk::3553fc2e-875d-4b8e-9341-9209134c3454" providerId="AD" clId="Web-{E7361B5A-EB23-0794-CE6A-15FBCF7DDB4B}" dt="2026-01-22T11:07:19.760" v="116"/>
+      <pc:sldChg chg="modSp ord">
+        <pc:chgData name="Alex Rush" userId="S::alex.rush@mail.bcu.ac.uk::3553fc2e-875d-4b8e-9341-9209134c3454" providerId="AD" clId="Web-{E7361B5A-EB23-0794-CE6A-15FBCF7DDB4B}" dt="2026-01-22T15:52:04.048" v="570" actId="20577"/>
         <pc:sldMkLst>
           <pc:docMk/>
           <pc:sldMk cId="3427033946" sldId="652"/>
         </pc:sldMkLst>
+        <pc:spChg chg="mod">
+          <ac:chgData name="Alex Rush" userId="S::alex.rush@mail.bcu.ac.uk::3553fc2e-875d-4b8e-9341-9209134c3454" providerId="AD" clId="Web-{E7361B5A-EB23-0794-CE6A-15FBCF7DDB4B}" dt="2026-01-22T15:52:04.048" v="570" actId="20577"/>
+          <ac:spMkLst>
+            <pc:docMk/>
+            <pc:sldMk cId="3427033946" sldId="652"/>
+            <ac:spMk id="7" creationId="{4BD173E2-0442-FDBD-0BB2-C21679EF9473}"/>
+          </ac:spMkLst>
+        </pc:spChg>
       </pc:sldChg>
       <pc:sldChg chg="modSp">
         <pc:chgData name="Alex Rush" userId="S::alex.rush@mail.bcu.ac.uk::3553fc2e-875d-4b8e-9341-9209134c3454" providerId="AD" clId="Web-{E7361B5A-EB23-0794-CE6A-15FBCF7DDB4B}" dt="2026-01-22T11:06:53.181" v="113" actId="20577"/>
@@ -398,7 +595,7 @@
   <pc:docChgLst>
     <pc:chgData name="Daniel Roberts" userId="S::daniel.roberts4@mail.bcu.ac.uk::75271c38-e632-4765-a405-8e8dc3d15425" providerId="AD" clId="Web-{3621F125-8D30-569F-5FED-6D29C84ECEDE}"/>
     <pc:docChg chg="modSld sldOrd">
-      <pc:chgData name="Daniel Roberts" userId="S::daniel.roberts4@mail.bcu.ac.uk::75271c38-e632-4765-a405-8e8dc3d15425" providerId="AD" clId="Web-{3621F125-8D30-569F-5FED-6D29C84ECEDE}" dt="2026-01-22T13:23:46.283" v="336" actId="14100"/>
+      <pc:chgData name="Daniel Roberts" userId="S::daniel.roberts4@mail.bcu.ac.uk::75271c38-e632-4765-a405-8e8dc3d15425" providerId="AD" clId="Web-{3621F125-8D30-569F-5FED-6D29C84ECEDE}" dt="2026-01-22T15:58:47.427" v="342" actId="14100"/>
       <pc:docMkLst>
         <pc:docMk/>
       </pc:docMkLst>
@@ -418,13 +615,13 @@
         </pc:spChg>
       </pc:sldChg>
       <pc:sldChg chg="addSp delSp modSp">
-        <pc:chgData name="Daniel Roberts" userId="S::daniel.roberts4@mail.bcu.ac.uk::75271c38-e632-4765-a405-8e8dc3d15425" providerId="AD" clId="Web-{3621F125-8D30-569F-5FED-6D29C84ECEDE}" dt="2026-01-22T13:23:46.283" v="336" actId="14100"/>
+        <pc:chgData name="Daniel Roberts" userId="S::daniel.roberts4@mail.bcu.ac.uk::75271c38-e632-4765-a405-8e8dc3d15425" providerId="AD" clId="Web-{3621F125-8D30-569F-5FED-6D29C84ECEDE}" dt="2026-01-22T15:58:47.427" v="342" actId="14100"/>
         <pc:sldMkLst>
           <pc:docMk/>
           <pc:sldMk cId="3286701981" sldId="640"/>
         </pc:sldMkLst>
-        <pc:spChg chg="add mod">
-          <ac:chgData name="Daniel Roberts" userId="S::daniel.roberts4@mail.bcu.ac.uk::75271c38-e632-4765-a405-8e8dc3d15425" providerId="AD" clId="Web-{3621F125-8D30-569F-5FED-6D29C84ECEDE}" dt="2026-01-22T13:23:46.283" v="336" actId="14100"/>
+        <pc:spChg chg="add del mod">
+          <ac:chgData name="Daniel Roberts" userId="S::daniel.roberts4@mail.bcu.ac.uk::75271c38-e632-4765-a405-8e8dc3d15425" providerId="AD" clId="Web-{3621F125-8D30-569F-5FED-6D29C84ECEDE}" dt="2026-01-22T15:58:19.848" v="337"/>
           <ac:spMkLst>
             <pc:docMk/>
             <pc:sldMk cId="3286701981" sldId="640"/>
@@ -439,6 +636,14 @@
             <ac:spMk id="11" creationId="{C5FB43CD-2679-A2C6-10A8-553F0B1336BE}"/>
           </ac:spMkLst>
         </pc:spChg>
+        <pc:picChg chg="add mod ord">
+          <ac:chgData name="Daniel Roberts" userId="S::daniel.roberts4@mail.bcu.ac.uk::75271c38-e632-4765-a405-8e8dc3d15425" providerId="AD" clId="Web-{3621F125-8D30-569F-5FED-6D29C84ECEDE}" dt="2026-01-22T15:58:47.427" v="342" actId="14100"/>
+          <ac:picMkLst>
+            <pc:docMk/>
+            <pc:sldMk cId="3286701981" sldId="640"/>
+            <ac:picMk id="3" creationId="{B80EF2E0-CF9F-DDA4-EDD5-5DE343A0FFC1}"/>
+          </ac:picMkLst>
+        </pc:picChg>
         <pc:picChg chg="del">
           <ac:chgData name="Daniel Roberts" userId="S::daniel.roberts4@mail.bcu.ac.uk::75271c38-e632-4765-a405-8e8dc3d15425" providerId="AD" clId="Web-{3621F125-8D30-569F-5FED-6D29C84ECEDE}" dt="2026-01-22T12:43:17.885" v="333"/>
           <ac:picMkLst>
@@ -1147,31 +1352,31 @@
           <a:lstStyle/>
           <a:p>
             <a:r>
-              <a:rPr lang="en-GB" dirty="0"/>
+              <a:rPr lang="en-GB"/>
               <a:t>“This is our D3 project submission for CMP5387 our group was: student 1, student 2, student 3, student 4, and student 4”</a:t>
             </a:r>
           </a:p>
           <a:p>
-            <a:endParaRPr lang="en-GB" dirty="0"/>
-          </a:p>
-          <a:p>
-            <a:r>
-              <a:rPr lang="en-GB" dirty="0"/>
+            <a:endParaRPr lang="en-GB"/>
+          </a:p>
+          <a:p>
+            <a:r>
+              <a:rPr lang="en-GB"/>
               <a:t>Note: You should not specify their student IDs or email addresses verbally, just their names</a:t>
             </a:r>
           </a:p>
           <a:p>
             <a:r>
-              <a:rPr lang="en-GB" dirty="0"/>
+              <a:rPr lang="en-GB"/>
               <a:t>The presence of this other info in the slide is enough.</a:t>
             </a:r>
           </a:p>
           <a:p>
-            <a:endParaRPr lang="en-GB" dirty="0"/>
-          </a:p>
-          <a:p>
-            <a:r>
-              <a:rPr lang="en-GB" dirty="0"/>
+            <a:endParaRPr lang="en-GB"/>
+          </a:p>
+          <a:p>
+            <a:r>
+              <a:rPr lang="en-GB"/>
               <a:t>Don’t spend too long on this slide just introduce the team members and move ahead, this shouldn’t be more than a few seconds long.</a:t>
             </a:r>
           </a:p>
@@ -1275,12 +1480,12 @@
               <a:defRPr/>
             </a:pPr>
             <a:r>
-              <a:rPr lang="en-GB" dirty="0"/>
+              <a:rPr lang="en-GB"/>
               <a:t>Discuss the implementation, linking the code with the physical design</a:t>
             </a:r>
           </a:p>
           <a:p>
-            <a:endParaRPr lang="en-GB" dirty="0"/>
+            <a:endParaRPr lang="en-GB"/>
           </a:p>
         </p:txBody>
       </p:sp>
@@ -1382,12 +1587,12 @@
               <a:defRPr/>
             </a:pPr>
             <a:r>
-              <a:rPr lang="en-GB" dirty="0"/>
+              <a:rPr lang="en-GB"/>
               <a:t>Estimated time: 3-6 minutes</a:t>
             </a:r>
           </a:p>
           <a:p>
-            <a:endParaRPr lang="en-GB" dirty="0"/>
+            <a:endParaRPr lang="en-GB"/>
           </a:p>
         </p:txBody>
       </p:sp>
@@ -1471,7 +1676,7 @@
           <a:bodyPr/>
           <a:lstStyle/>
           <a:p>
-            <a:endParaRPr lang="en-GB" dirty="0"/>
+            <a:endParaRPr lang="en-GB"/>
           </a:p>
         </p:txBody>
       </p:sp>
@@ -1573,7 +1778,7 @@
           <a:bodyPr/>
           <a:lstStyle/>
           <a:p>
-            <a:endParaRPr lang="en-GB" dirty="0"/>
+            <a:endParaRPr lang="en-GB"/>
           </a:p>
         </p:txBody>
       </p:sp>
@@ -1663,7 +1868,7 @@
           <a:bodyPr/>
           <a:lstStyle/>
           <a:p>
-            <a:endParaRPr lang="en-GB" dirty="0"/>
+            <a:endParaRPr lang="en-GB"/>
           </a:p>
         </p:txBody>
       </p:sp>
@@ -1748,7 +1953,7 @@
           <a:lstStyle/>
           <a:p>
             <a:r>
-              <a:rPr lang="en-GB" dirty="0"/>
+              <a:rPr lang="en-GB"/>
               <a:t>Estimated time: 2-4 minutes</a:t>
             </a:r>
           </a:p>
@@ -1834,7 +2039,7 @@
           <a:bodyPr/>
           <a:lstStyle/>
           <a:p>
-            <a:endParaRPr lang="en-GB" dirty="0"/>
+            <a:endParaRPr lang="en-GB"/>
           </a:p>
         </p:txBody>
       </p:sp>
@@ -1918,7 +2123,7 @@
           <a:bodyPr/>
           <a:lstStyle/>
           <a:p>
-            <a:endParaRPr lang="en-GB" dirty="0"/>
+            <a:endParaRPr lang="en-GB"/>
           </a:p>
         </p:txBody>
       </p:sp>
@@ -2003,32 +2208,32 @@
           <a:lstStyle/>
           <a:p>
             <a:r>
-              <a:rPr lang="en-GB" dirty="0"/>
+              <a:rPr lang="en-GB"/>
               <a:t>Further advice and guidance regarding this will be released in the coming weeks.</a:t>
             </a:r>
           </a:p>
           <a:p>
-            <a:endParaRPr lang="en-GB" dirty="0"/>
-          </a:p>
-          <a:p>
-            <a:r>
-              <a:rPr lang="en-GB" dirty="0"/>
+            <a:endParaRPr lang="en-GB"/>
+          </a:p>
+          <a:p>
+            <a:r>
+              <a:rPr lang="en-GB"/>
               <a:t>In the meantime, consider that the video is an opportunity to present the most valuable contributions of each group member to the project, each group member should be able to demonstrate they have contributed to </a:t>
             </a:r>
             <a:r>
-              <a:rPr lang="en-GB" b="1" dirty="0"/>
+              <a:rPr lang="en-GB" b="1"/>
               <a:t>both</a:t>
             </a:r>
             <a:r>
-              <a:rPr lang="en-GB" dirty="0"/>
+              <a:rPr lang="en-GB"/>
               <a:t> the database design / implementation </a:t>
             </a:r>
             <a:r>
-              <a:rPr lang="en-GB" b="1" dirty="0"/>
+              <a:rPr lang="en-GB" b="1"/>
               <a:t>and</a:t>
             </a:r>
             <a:r>
-              <a:rPr lang="en-GB" dirty="0"/>
+              <a:rPr lang="en-GB"/>
               <a:t> the web service / client design and implementation to demonstrate they have met the learning outcomes for the module.</a:t>
             </a:r>
           </a:p>
@@ -2037,7 +2242,7 @@
               <a:buFont typeface="Arial" panose="020B0604020202020204" pitchFamily="34" charset="0"/>
               <a:buNone/>
             </a:pPr>
-            <a:endParaRPr lang="en-GB" dirty="0"/>
+            <a:endParaRPr lang="en-GB"/>
           </a:p>
           <a:p>
             <a:pPr marL="0" indent="0">
@@ -2045,7 +2250,7 @@
               <a:buNone/>
             </a:pPr>
             <a:r>
-              <a:rPr lang="en-GB" dirty="0"/>
+              <a:rPr lang="en-GB"/>
               <a:t>Remember the assessment asks that you demonstrate the four learning outcomes throughout the module:</a:t>
             </a:r>
           </a:p>
@@ -2055,7 +2260,7 @@
               <a:buChar char="•"/>
             </a:pPr>
             <a:r>
-              <a:rPr lang="en-GB" dirty="0"/>
+              <a:rPr lang="en-GB"/>
               <a:t>Identify, document, and model the planning and design requirements for a given backend web service, by leveraging appropriate software engineering technique</a:t>
             </a:r>
           </a:p>
@@ -2065,7 +2270,7 @@
               <a:buChar char="•"/>
             </a:pPr>
             <a:r>
-              <a:rPr lang="en-GB" dirty="0"/>
+              <a:rPr lang="en-GB"/>
               <a:t>Design and construct a well justified and appropriate Database architecture, using an appropriate assortment of query languages and tools on a host DBMS (e.g. SQL for RDBMS system, GQL/Cypher for GDBMS, etc). </a:t>
             </a:r>
           </a:p>
@@ -2075,7 +2280,7 @@
               <a:buChar char="•"/>
             </a:pPr>
             <a:r>
-              <a:rPr lang="en-GB" dirty="0"/>
+              <a:rPr lang="en-GB"/>
               <a:t>Demonstrate development skills through the planning and implementation of a sufficiently justified backend web service and effectively link this with a client system using an assortment of appropriate tools and techniques (e.g. leveraging web microframeworks for the backend, with client-side scripting in JavaScript) </a:t>
             </a:r>
           </a:p>
@@ -2085,7 +2290,7 @@
               <a:buChar char="•"/>
             </a:pPr>
             <a:r>
-              <a:rPr lang="en-GB" dirty="0"/>
+              <a:rPr lang="en-GB"/>
               <a:t>Evidence the ability to critique and evaluate the capabilities of the system, and defend the overall approach taken in terms of its suitability to meet an appropriate set of requirements (functional and non-functional). </a:t>
             </a:r>
           </a:p>
@@ -2172,7 +2377,7 @@
           <a:lstStyle/>
           <a:p>
             <a:r>
-              <a:rPr lang="en-GB" dirty="0"/>
+              <a:rPr lang="en-GB"/>
               <a:t>Spend only a few seconds stating the title of the project idea, don’t waste too much time on this slide it shouldn’t be more than a few seconds long.</a:t>
             </a:r>
           </a:p>
@@ -2259,17 +2464,17 @@
           <a:lstStyle/>
           <a:p>
             <a:r>
-              <a:rPr lang="en-GB" dirty="0"/>
+              <a:rPr lang="en-GB"/>
               <a:t>Some of this section will have already been discussed in your questionnaire form submission and your planning and design document, as such keep things succinct and focus on the major important aspects you want to draw the audience’s attention to</a:t>
             </a:r>
             <a:br>
-              <a:rPr lang="en-GB" dirty="0"/>
+              <a:rPr lang="en-GB"/>
             </a:br>
             <a:br>
-              <a:rPr lang="en-GB" dirty="0"/>
+              <a:rPr lang="en-GB"/>
             </a:br>
             <a:r>
-              <a:rPr lang="en-GB" dirty="0"/>
+              <a:rPr lang="en-GB"/>
               <a:t>Estimated time: 2-4 minutes</a:t>
             </a:r>
           </a:p>
@@ -2356,7 +2561,7 @@
           <a:lstStyle/>
           <a:p>
             <a:r>
-              <a:rPr lang="en-GB" dirty="0"/>
+              <a:rPr lang="en-GB"/>
               <a:t>Spend no more than a minute or so on this</a:t>
             </a:r>
           </a:p>
@@ -2556,12 +2761,12 @@
               <a:defRPr/>
             </a:pPr>
             <a:r>
-              <a:rPr lang="en-GB" dirty="0"/>
+              <a:rPr lang="en-GB"/>
               <a:t>Spend no more than a minute or so on this</a:t>
             </a:r>
           </a:p>
           <a:p>
-            <a:endParaRPr lang="en-GB" dirty="0"/>
+            <a:endParaRPr lang="en-GB"/>
           </a:p>
         </p:txBody>
       </p:sp>
@@ -2681,7 +2886,7 @@
               <a:defRPr/>
             </a:pPr>
             <a:r>
-              <a:rPr lang="en-GB" dirty="0">
+              <a:rPr lang="en-GB">
                 <a:solidFill>
                   <a:srgbClr val="FF0000"/>
                 </a:solidFill>
@@ -2708,7 +2913,7 @@
               <a:defRPr/>
             </a:pPr>
             <a:r>
-              <a:rPr lang="en-GB" dirty="0">
+              <a:rPr lang="en-GB">
                 <a:solidFill>
                   <a:srgbClr val="FF0000"/>
                 </a:solidFill>
@@ -2717,7 +2922,7 @@
             </a:r>
           </a:p>
           <a:p>
-            <a:endParaRPr lang="en-GB" dirty="0"/>
+            <a:endParaRPr lang="en-GB"/>
           </a:p>
         </p:txBody>
       </p:sp>
@@ -2825,12 +3030,12 @@
               <a:defRPr/>
             </a:pPr>
             <a:r>
-              <a:rPr lang="en-GB" dirty="0"/>
+              <a:rPr lang="en-GB"/>
               <a:t>Estimated time: 3-6 minutes</a:t>
             </a:r>
           </a:p>
           <a:p>
-            <a:endParaRPr lang="en-GB" dirty="0"/>
+            <a:endParaRPr lang="en-GB"/>
           </a:p>
         </p:txBody>
       </p:sp>
@@ -2915,13 +3120,13 @@
           <a:lstStyle/>
           <a:p>
             <a:r>
-              <a:rPr lang="en-GB" dirty="0"/>
+              <a:rPr lang="en-GB"/>
               <a:t>Justify your database design approach</a:t>
             </a:r>
           </a:p>
           <a:p>
             <a:r>
-              <a:rPr lang="en-GB" dirty="0"/>
+              <a:rPr lang="en-GB"/>
               <a:t>How are you:</a:t>
             </a:r>
           </a:p>
@@ -2931,7 +3136,7 @@
               <a:buChar char="•"/>
             </a:pPr>
             <a:r>
-              <a:rPr lang="en-GB" dirty="0"/>
+              <a:rPr lang="en-GB"/>
               <a:t>Capturing all the data necessary for the system?</a:t>
             </a:r>
           </a:p>
@@ -2941,7 +3146,7 @@
               <a:buChar char="•"/>
             </a:pPr>
             <a:r>
-              <a:rPr lang="en-GB" dirty="0"/>
+              <a:rPr lang="en-GB"/>
               <a:t>Minimising duplication?</a:t>
             </a:r>
           </a:p>
@@ -2951,15 +3156,15 @@
               <a:buChar char="•"/>
             </a:pPr>
             <a:r>
-              <a:rPr lang="en-GB" dirty="0"/>
+              <a:rPr lang="en-GB"/>
               <a:t>Providing a flexible structure which could be extended in the future?</a:t>
             </a:r>
           </a:p>
           <a:p>
-            <a:endParaRPr lang="en-GB" dirty="0"/>
-          </a:p>
-          <a:p>
-            <a:endParaRPr lang="en-GB" dirty="0"/>
+            <a:endParaRPr lang="en-GB"/>
+          </a:p>
+          <a:p>
+            <a:endParaRPr lang="en-GB"/>
           </a:p>
         </p:txBody>
       </p:sp>
@@ -3044,7 +3249,7 @@
           <a:lstStyle/>
           <a:p>
             <a:r>
-              <a:rPr lang="en-GB" dirty="0"/>
+              <a:rPr lang="en-GB"/>
               <a:t>Discuss the implementation, linking the code with the physical design</a:t>
             </a:r>
           </a:p>
@@ -9171,7 +9376,7 @@
               <a:defRPr/>
             </a:pPr>
             <a:r>
-              <a:rPr kumimoji="0" lang="en-GB" sz="3800" b="1" i="0" u="none" strike="noStrike" kern="1200" cap="none" spc="0" normalizeH="0" baseline="0" noProof="0" dirty="0">
+              <a:rPr kumimoji="0" lang="en-GB" sz="3800" b="1" i="0" u="none" strike="noStrike" kern="1200" cap="none" spc="0" normalizeH="0" baseline="0" noProof="0">
                 <a:ln>
                   <a:noFill/>
                 </a:ln>
@@ -9296,7 +9501,7 @@
             <a:pPr>
               <a:defRPr/>
             </a:pPr>
-            <a:endParaRPr lang="en-GB" sz="1400" b="1" dirty="0">
+            <a:endParaRPr lang="en-GB" sz="1400" b="1">
               <a:solidFill>
                 <a:prstClr val="white"/>
               </a:solidFill>
@@ -9315,7 +9520,7 @@
             <a:pPr>
               <a:defRPr/>
             </a:pPr>
-            <a:endParaRPr lang="en-GB" sz="1400" b="1" dirty="0">
+            <a:endParaRPr lang="en-GB" sz="1400" b="1">
               <a:solidFill>
                 <a:prstClr val="white"/>
               </a:solidFill>
@@ -9348,7 +9553,7 @@
               <a:tabLst/>
               <a:defRPr/>
             </a:pPr>
-            <a:endParaRPr lang="en-GB" sz="1400" b="1" dirty="0">
+            <a:endParaRPr lang="en-GB" sz="1400" b="1">
               <a:solidFill>
                 <a:prstClr val="white"/>
               </a:solidFill>
@@ -9382,7 +9587,7 @@
               <a:defRPr/>
             </a:pPr>
             <a:r>
-              <a:rPr kumimoji="0" lang="en-GB" sz="1400" b="1" i="0" u="none" strike="noStrike" kern="1200" cap="none" spc="0" normalizeH="0" baseline="0" noProof="0" dirty="0">
+              <a:rPr kumimoji="0" lang="en-GB" sz="1400" b="1" i="0" u="none" strike="noStrike" kern="1200" cap="none" spc="0" normalizeH="0" baseline="0" noProof="0">
                 <a:ln>
                   <a:noFill/>
                 </a:ln>
@@ -9465,7 +9670,7 @@
           <a:lstStyle/>
           <a:p>
             <a:r>
-              <a:rPr lang="en-GB" dirty="0"/>
+              <a:rPr lang="en-GB"/>
               <a:t>Database Implementation</a:t>
             </a:r>
           </a:p>
@@ -9494,7 +9699,7 @@
           </a:bodyPr>
           <a:lstStyle/>
           <a:p>
-            <a:endParaRPr lang="en-GB" dirty="0"/>
+            <a:endParaRPr lang="en-GB"/>
           </a:p>
         </p:txBody>
       </p:sp>
@@ -9522,7 +9727,7 @@
           <a:lstStyle/>
           <a:p>
             <a:r>
-              <a:rPr lang="en-GB" dirty="0">
+              <a:rPr lang="en-GB">
                 <a:solidFill>
                   <a:srgbClr val="FF0000"/>
                 </a:solidFill>
@@ -9532,7 +9737,7 @@
           </a:p>
           <a:p>
             <a:r>
-              <a:rPr lang="en-GB" dirty="0">
+              <a:rPr lang="en-GB">
                 <a:solidFill>
                   <a:srgbClr val="FF0000"/>
                 </a:solidFill>
@@ -9543,7 +9748,7 @@
           <a:p>
             <a:pPr lvl="1"/>
             <a:r>
-              <a:rPr lang="en-GB" dirty="0">
+              <a:rPr lang="en-GB">
                 <a:solidFill>
                   <a:srgbClr val="FF0000"/>
                 </a:solidFill>
@@ -9554,7 +9759,7 @@
           <a:p>
             <a:pPr lvl="1"/>
             <a:r>
-              <a:rPr lang="en-GB" dirty="0">
+              <a:rPr lang="en-GB">
                 <a:solidFill>
                   <a:srgbClr val="FF0000"/>
                 </a:solidFill>
@@ -9565,7 +9770,7 @@
           <a:p>
             <a:pPr lvl="2"/>
             <a:r>
-              <a:rPr lang="en-GB" dirty="0">
+              <a:rPr lang="en-GB">
                 <a:solidFill>
                   <a:srgbClr val="FF0000"/>
                 </a:solidFill>
@@ -9574,7 +9779,7 @@
             </a:r>
           </a:p>
           <a:p>
-            <a:endParaRPr lang="en-GB" dirty="0"/>
+            <a:endParaRPr lang="en-GB"/>
           </a:p>
         </p:txBody>
       </p:sp>
@@ -9630,22 +9835,22 @@
           <a:noFill/>
         </p:spPr>
         <p:txBody>
-          <a:bodyPr wrap="square" rtlCol="0">
+          <a:bodyPr wrap="square" lIns="91440" tIns="45720" rIns="91440" bIns="45720" rtlCol="0" anchor="t">
             <a:spAutoFit/>
           </a:bodyPr>
           <a:lstStyle/>
           <a:p>
             <a:r>
-              <a:rPr lang="en-GB" dirty="0"/>
+              <a:rPr lang="en-GB"/>
               <a:t>Presenting Team Member: </a:t>
             </a:r>
             <a:r>
-              <a:rPr lang="en-GB" dirty="0">
+              <a:rPr lang="en-GB">
                 <a:solidFill>
                   <a:srgbClr val="FF0000"/>
                 </a:solidFill>
               </a:rPr>
-              <a:t>Student 1</a:t>
+              <a:t>Alex</a:t>
             </a:r>
           </a:p>
         </p:txBody>
@@ -9791,7 +9996,7 @@
           <a:p>
             <a:pPr algn="ctr"/>
             <a:r>
-              <a:rPr lang="en-GB" dirty="0">
+              <a:rPr lang="en-GB">
                 <a:solidFill>
                   <a:srgbClr val="FF0000"/>
                 </a:solidFill>
@@ -9799,14 +10004,14 @@
               <a:t>Web Service </a:t>
             </a:r>
             <a:br>
-              <a:rPr lang="en-GB" dirty="0">
+              <a:rPr lang="en-GB">
                 <a:solidFill>
                   <a:srgbClr val="FF0000"/>
                 </a:solidFill>
               </a:rPr>
             </a:br>
             <a:r>
-              <a:rPr lang="en-GB" dirty="0">
+              <a:rPr lang="en-GB">
                 <a:solidFill>
                   <a:srgbClr val="FF0000"/>
                 </a:solidFill>
@@ -9838,7 +10043,7 @@
           <a:lstStyle/>
           <a:p>
             <a:r>
-              <a:rPr lang="en-GB" dirty="0">
+              <a:rPr lang="en-GB">
                 <a:solidFill>
                   <a:srgbClr val="FF0000"/>
                 </a:solidFill>
@@ -9900,7 +10105,7 @@
           <a:lstStyle/>
           <a:p>
             <a:r>
-              <a:rPr lang="en-GB" dirty="0"/>
+              <a:rPr lang="en-GB"/>
               <a:t>Web Service Implementation</a:t>
             </a:r>
           </a:p>
@@ -9924,17 +10129,249 @@
         </p:nvSpPr>
         <p:spPr/>
         <p:txBody>
-          <a:bodyPr/>
-          <a:lstStyle/>
-          <a:p>
-            <a:r>
-              <a:rPr lang="en-GB" dirty="0">
+          <a:bodyPr vert="horz" lIns="91440" tIns="45720" rIns="91440" bIns="45720" rtlCol="0" anchor="t">
+            <a:normAutofit fontScale="92500" lnSpcReduction="20000"/>
+          </a:bodyPr>
+          <a:lstStyle/>
+          <a:p>
+            <a:r>
+              <a:rPr lang="en-GB">
+                <a:solidFill>
+                  <a:schemeClr val="tx1">
+                    <a:lumMod val="85000"/>
+                    <a:lumOff val="15000"/>
+                  </a:schemeClr>
+                </a:solidFill>
+                <a:ea typeface="+mn-lt"/>
+                <a:cs typeface="+mn-lt"/>
+              </a:rPr>
+              <a:t>A </a:t>
+            </a:r>
+            <a:r>
+              <a:rPr lang="en-GB" b="1">
                 <a:solidFill>
                   <a:srgbClr val="FF0000"/>
                 </a:solidFill>
+                <a:ea typeface="+mn-lt"/>
+                <a:cs typeface="+mn-lt"/>
               </a:rPr>
-              <a:t>Define what a web service is</a:t>
-            </a:r>
+              <a:t>web service</a:t>
+            </a:r>
+            <a:r>
+              <a:rPr lang="en-GB">
+                <a:solidFill>
+                  <a:schemeClr val="tx1">
+                    <a:lumMod val="85000"/>
+                    <a:lumOff val="15000"/>
+                  </a:schemeClr>
+                </a:solidFill>
+                <a:ea typeface="+mn-lt"/>
+                <a:cs typeface="+mn-lt"/>
+              </a:rPr>
+              <a:t> enables different applications to communicate over the internet using standard protocols such as </a:t>
+            </a:r>
+            <a:r>
+              <a:rPr lang="en-GB" b="1">
+                <a:solidFill>
+                  <a:schemeClr val="tx1">
+                    <a:lumMod val="85000"/>
+                    <a:lumOff val="15000"/>
+                  </a:schemeClr>
+                </a:solidFill>
+                <a:ea typeface="+mn-lt"/>
+                <a:cs typeface="+mn-lt"/>
+              </a:rPr>
+              <a:t>HTTP</a:t>
+            </a:r>
+            <a:r>
+              <a:rPr lang="en-GB">
+                <a:solidFill>
+                  <a:schemeClr val="tx1">
+                    <a:lumMod val="85000"/>
+                    <a:lumOff val="15000"/>
+                  </a:schemeClr>
+                </a:solidFill>
+                <a:ea typeface="+mn-lt"/>
+                <a:cs typeface="+mn-lt"/>
+              </a:rPr>
+              <a:t>.</a:t>
+            </a:r>
+            <a:endParaRPr lang="en-GB">
+              <a:solidFill>
+                <a:schemeClr val="tx1">
+                  <a:lumMod val="85000"/>
+                  <a:lumOff val="15000"/>
+                </a:schemeClr>
+              </a:solidFill>
+              <a:ea typeface="Calibri"/>
+              <a:cs typeface="Calibri"/>
+            </a:endParaRPr>
+          </a:p>
+          <a:p>
+            <a:r>
+              <a:rPr lang="en-GB">
+                <a:solidFill>
+                  <a:schemeClr val="tx1">
+                    <a:lumMod val="85000"/>
+                    <a:lumOff val="15000"/>
+                  </a:schemeClr>
+                </a:solidFill>
+                <a:ea typeface="+mn-lt"/>
+                <a:cs typeface="+mn-lt"/>
+              </a:rPr>
+              <a:t>In this system, the web service acts as the </a:t>
+            </a:r>
+            <a:r>
+              <a:rPr lang="en-GB" b="1">
+                <a:solidFill>
+                  <a:schemeClr val="tx1">
+                    <a:lumMod val="85000"/>
+                    <a:lumOff val="15000"/>
+                  </a:schemeClr>
+                </a:solidFill>
+                <a:ea typeface="+mn-lt"/>
+                <a:cs typeface="+mn-lt"/>
+              </a:rPr>
+              <a:t>backend</a:t>
+            </a:r>
+            <a:r>
+              <a:rPr lang="en-GB">
+                <a:solidFill>
+                  <a:schemeClr val="tx1">
+                    <a:lumMod val="85000"/>
+                    <a:lumOff val="15000"/>
+                  </a:schemeClr>
+                </a:solidFill>
+                <a:ea typeface="+mn-lt"/>
+                <a:cs typeface="+mn-lt"/>
+              </a:rPr>
+              <a:t>, handling client requests, applying business logic, interacting with the database, and returning data in </a:t>
+            </a:r>
+            <a:r>
+              <a:rPr lang="en-GB" b="1">
+                <a:solidFill>
+                  <a:schemeClr val="tx1">
+                    <a:lumMod val="85000"/>
+                    <a:lumOff val="15000"/>
+                  </a:schemeClr>
+                </a:solidFill>
+                <a:ea typeface="+mn-lt"/>
+                <a:cs typeface="+mn-lt"/>
+              </a:rPr>
+              <a:t>JSON format</a:t>
+            </a:r>
+            <a:r>
+              <a:rPr lang="en-GB">
+                <a:solidFill>
+                  <a:schemeClr val="tx1">
+                    <a:lumMod val="85000"/>
+                    <a:lumOff val="15000"/>
+                  </a:schemeClr>
+                </a:solidFill>
+                <a:ea typeface="+mn-lt"/>
+                <a:cs typeface="+mn-lt"/>
+              </a:rPr>
+              <a:t>.</a:t>
+            </a:r>
+            <a:endParaRPr lang="en-GB">
+              <a:solidFill>
+                <a:schemeClr val="tx1">
+                  <a:lumMod val="85000"/>
+                  <a:lumOff val="15000"/>
+                </a:schemeClr>
+              </a:solidFill>
+              <a:ea typeface="Calibri"/>
+              <a:cs typeface="Calibri"/>
+            </a:endParaRPr>
+          </a:p>
+          <a:p>
+            <a:r>
+              <a:rPr lang="en-GB">
+                <a:solidFill>
+                  <a:schemeClr val="tx1">
+                    <a:lumMod val="85000"/>
+                    <a:lumOff val="15000"/>
+                  </a:schemeClr>
+                </a:solidFill>
+                <a:ea typeface="+mn-lt"/>
+                <a:cs typeface="+mn-lt"/>
+              </a:rPr>
+              <a:t>The service follows </a:t>
+            </a:r>
+            <a:r>
+              <a:rPr lang="en-GB" b="1">
+                <a:solidFill>
+                  <a:schemeClr val="tx1">
+                    <a:lumMod val="85000"/>
+                    <a:lumOff val="15000"/>
+                  </a:schemeClr>
+                </a:solidFill>
+                <a:ea typeface="+mn-lt"/>
+                <a:cs typeface="+mn-lt"/>
+              </a:rPr>
+              <a:t>RESTful principles</a:t>
+            </a:r>
+            <a:r>
+              <a:rPr lang="en-GB">
+                <a:solidFill>
+                  <a:schemeClr val="tx1">
+                    <a:lumMod val="85000"/>
+                    <a:lumOff val="15000"/>
+                  </a:schemeClr>
+                </a:solidFill>
+                <a:ea typeface="+mn-lt"/>
+                <a:cs typeface="+mn-lt"/>
+              </a:rPr>
+              <a:t>, using endpoints and HTTP methods (GET, POST, etc.) to access resources in a </a:t>
+            </a:r>
+            <a:r>
+              <a:rPr lang="en-GB" b="1">
+                <a:solidFill>
+                  <a:schemeClr val="tx1">
+                    <a:lumMod val="85000"/>
+                    <a:lumOff val="15000"/>
+                  </a:schemeClr>
+                </a:solidFill>
+                <a:ea typeface="+mn-lt"/>
+                <a:cs typeface="+mn-lt"/>
+              </a:rPr>
+              <a:t>stateless and scalable</a:t>
+            </a:r>
+            <a:r>
+              <a:rPr lang="en-GB">
+                <a:solidFill>
+                  <a:schemeClr val="tx1">
+                    <a:lumMod val="85000"/>
+                    <a:lumOff val="15000"/>
+                  </a:schemeClr>
+                </a:solidFill>
+                <a:ea typeface="+mn-lt"/>
+                <a:cs typeface="+mn-lt"/>
+              </a:rPr>
+              <a:t> way.</a:t>
+            </a:r>
+            <a:endParaRPr lang="en-GB">
+              <a:solidFill>
+                <a:schemeClr val="tx1">
+                  <a:lumMod val="85000"/>
+                  <a:lumOff val="15000"/>
+                </a:schemeClr>
+              </a:solidFill>
+              <a:ea typeface="Calibri"/>
+              <a:cs typeface="Calibri"/>
+            </a:endParaRPr>
+          </a:p>
+          <a:p>
+            <a:endParaRPr lang="en-GB">
+              <a:solidFill>
+                <a:schemeClr val="tx1">
+                  <a:lumMod val="85000"/>
+                  <a:lumOff val="15000"/>
+                </a:schemeClr>
+              </a:solidFill>
+              <a:ea typeface="Calibri"/>
+              <a:cs typeface="Calibri"/>
+            </a:endParaRPr>
           </a:p>
         </p:txBody>
       </p:sp>
@@ -9967,38 +10404,6 @@
           </a:p>
         </p:txBody>
       </p:sp>
-      <p:pic>
-        <p:nvPicPr>
-          <p:cNvPr id="6" name="Content Placeholder 5">
-            <a:extLst>
-              <a:ext uri="{FF2B5EF4-FFF2-40B4-BE49-F238E27FC236}">
-                <a16:creationId xmlns:a16="http://schemas.microsoft.com/office/drawing/2014/main" id="{AA6D55E1-219E-318E-E15F-FB765DF2AFDC}"/>
-              </a:ext>
-            </a:extLst>
-          </p:cNvPr>
-          <p:cNvPicPr>
-            <a:picLocks noGrp="1" noChangeAspect="1"/>
-          </p:cNvPicPr>
-          <p:nvPr>
-            <p:ph sz="half" idx="1"/>
-          </p:nvPr>
-        </p:nvPicPr>
-        <p:blipFill>
-          <a:blip r:embed="rId3"/>
-          <a:stretch>
-            <a:fillRect/>
-          </a:stretch>
-        </p:blipFill>
-        <p:spPr>
-          <a:xfrm>
-            <a:off x="838200" y="2074226"/>
-            <a:ext cx="5181600" cy="3854135"/>
-          </a:xfrm>
-          <a:prstGeom prst="rect">
-            <a:avLst/>
-          </a:prstGeom>
-        </p:spPr>
-      </p:pic>
       <p:pic>
         <p:nvPicPr>
           <p:cNvPr id="7" name="Picture 6">
@@ -10014,7 +10419,7 @@
           <p:nvPr/>
         </p:nvPicPr>
         <p:blipFill>
-          <a:blip r:embed="rId4"/>
+          <a:blip r:embed="rId3"/>
           <a:stretch>
             <a:fillRect/>
           </a:stretch>
@@ -10052,23 +10457,96 @@
           <a:noFill/>
         </p:spPr>
         <p:txBody>
-          <a:bodyPr wrap="square">
+          <a:bodyPr wrap="square" lIns="91440" tIns="45720" rIns="91440" bIns="45720" anchor="t">
             <a:spAutoFit/>
           </a:bodyPr>
           <a:lstStyle/>
           <a:p>
             <a:r>
-              <a:rPr lang="en-GB" dirty="0"/>
-              <a:t>Presenting Team Member: </a:t>
-            </a:r>
-            <a:r>
-              <a:rPr lang="en-GB" dirty="0">
-                <a:solidFill>
-                  <a:srgbClr val="FF0000"/>
-                </a:solidFill>
+              <a:rPr lang="en-GB"/>
+              <a:t>Presenting Team Member: Abraham</a:t>
+            </a:r>
+            <a:endParaRPr lang="en-GB">
+              <a:solidFill>
+                <a:srgbClr val="FF0000"/>
+              </a:solidFill>
+              <a:ea typeface="Calibri"/>
+              <a:cs typeface="Calibri"/>
+            </a:endParaRPr>
+          </a:p>
+        </p:txBody>
+      </p:sp>
+      <p:pic>
+        <p:nvPicPr>
+          <p:cNvPr id="12" name="Content Placeholder 11" descr="A diagram of a server&#10;&#10;AI-generated content may be incorrect.">
+            <a:extLst>
+              <a:ext uri="{FF2B5EF4-FFF2-40B4-BE49-F238E27FC236}">
+                <a16:creationId xmlns:a16="http://schemas.microsoft.com/office/drawing/2014/main" id="{B78A246C-7B40-6767-EE88-50FE19B92103}"/>
+              </a:ext>
+            </a:extLst>
+          </p:cNvPr>
+          <p:cNvPicPr>
+            <a:picLocks noGrp="1" noChangeAspect="1"/>
+          </p:cNvPicPr>
+          <p:nvPr>
+            <p:ph sz="half" idx="1"/>
+          </p:nvPr>
+        </p:nvPicPr>
+        <p:blipFill>
+          <a:blip r:embed="rId4"/>
+          <a:stretch>
+            <a:fillRect/>
+          </a:stretch>
+        </p:blipFill>
+        <p:spPr>
+          <a:xfrm>
+            <a:off x="838200" y="2425463"/>
+            <a:ext cx="5192809" cy="2669808"/>
+          </a:xfrm>
+          <a:prstGeom prst="rect">
+            <a:avLst/>
+          </a:prstGeom>
+        </p:spPr>
+      </p:pic>
+      <p:sp>
+        <p:nvSpPr>
+          <p:cNvPr id="13" name="TextBox 12">
+            <a:extLst>
+              <a:ext uri="{FF2B5EF4-FFF2-40B4-BE49-F238E27FC236}">
+                <a16:creationId xmlns:a16="http://schemas.microsoft.com/office/drawing/2014/main" id="{688008E0-DB2D-0F1C-D927-7599BF2F98E4}"/>
+              </a:ext>
+            </a:extLst>
+          </p:cNvPr>
+          <p:cNvSpPr txBox="1"/>
+          <p:nvPr/>
+        </p:nvSpPr>
+        <p:spPr>
+          <a:xfrm>
+            <a:off x="934044" y="1774685"/>
+            <a:ext cx="4558137" cy="461665"/>
+          </a:xfrm>
+          <a:prstGeom prst="rect">
+            <a:avLst/>
+          </a:prstGeom>
+          <a:noFill/>
+        </p:spPr>
+        <p:txBody>
+          <a:bodyPr rot="0" spcFirstLastPara="0" vertOverflow="overflow" horzOverflow="overflow" vert="horz" wrap="square" lIns="91440" tIns="45720" rIns="91440" bIns="45720" numCol="1" spcCol="0" rtlCol="0" fromWordArt="0" anchor="t" anchorCtr="0" forceAA="0" compatLnSpc="1">
+            <a:prstTxWarp prst="textNoShape">
+              <a:avLst/>
+            </a:prstTxWarp>
+            <a:spAutoFit/>
+          </a:bodyPr>
+          <a:lstStyle/>
+          <a:p>
+            <a:r>
+              <a:rPr lang="en-GB" sz="2400" b="1">
+                <a:ea typeface="Calibri"/>
+                <a:cs typeface="Calibri"/>
               </a:rPr>
-              <a:t>Student 2</a:t>
-            </a:r>
+              <a:t>System Architecture Overview</a:t>
+            </a:r>
+            <a:endParaRPr lang="en-GB" sz="2400" b="1"/>
           </a:p>
         </p:txBody>
       </p:sp>
@@ -10135,7 +10613,7 @@
           <a:lstStyle/>
           <a:p>
             <a:r>
-              <a:rPr lang="en-GB" dirty="0"/>
+              <a:rPr lang="en-GB"/>
               <a:t>Web Service Implementation</a:t>
             </a:r>
           </a:p>
@@ -10165,7 +10643,7 @@
           <a:lstStyle/>
           <a:p>
             <a:r>
-              <a:rPr lang="en-GB" dirty="0">
+              <a:rPr lang="en-GB">
                 <a:solidFill>
                   <a:srgbClr val="FF0000"/>
                 </a:solidFill>
@@ -10175,7 +10653,7 @@
           </a:p>
           <a:p>
             <a:r>
-              <a:rPr lang="en-GB" dirty="0">
+              <a:rPr lang="en-GB">
                 <a:solidFill>
                   <a:srgbClr val="FF0000"/>
                 </a:solidFill>
@@ -10186,7 +10664,7 @@
           <a:p>
             <a:pPr lvl="1"/>
             <a:r>
-              <a:rPr lang="en-GB" dirty="0">
+              <a:rPr lang="en-GB">
                 <a:solidFill>
                   <a:srgbClr val="FF0000"/>
                 </a:solidFill>
@@ -10197,7 +10675,7 @@
           <a:p>
             <a:pPr lvl="1"/>
             <a:r>
-              <a:rPr lang="en-GB" dirty="0">
+              <a:rPr lang="en-GB">
                 <a:solidFill>
                   <a:srgbClr val="FF0000"/>
                 </a:solidFill>
@@ -10208,7 +10686,7 @@
           <a:p>
             <a:pPr lvl="2"/>
             <a:r>
-              <a:rPr lang="en-GB" dirty="0">
+              <a:rPr lang="en-GB">
                 <a:solidFill>
                   <a:srgbClr val="FF0000"/>
                 </a:solidFill>
@@ -10300,7 +10778,7 @@
                     <a:lstStyle/>
                     <a:p>
                       <a:r>
-                        <a:rPr lang="en-GB" dirty="0"/>
+                        <a:rPr lang="en-GB"/>
                         <a:t>Endpoint</a:t>
                       </a:r>
                     </a:p>
@@ -10313,7 +10791,7 @@
                     <a:lstStyle/>
                     <a:p>
                       <a:r>
-                        <a:rPr lang="en-GB" dirty="0"/>
+                        <a:rPr lang="en-GB"/>
                         <a:t>HTTP Method(s)</a:t>
                       </a:r>
                     </a:p>
@@ -10333,7 +10811,7 @@
                     <a:lstStyle/>
                     <a:p>
                       <a:r>
-                        <a:rPr lang="en-GB" b="1" dirty="0"/>
+                        <a:rPr lang="en-GB" b="1"/>
                         <a:t>/order</a:t>
                       </a:r>
                     </a:p>
@@ -10346,7 +10824,7 @@
                     <a:lstStyle/>
                     <a:p>
                       <a:r>
-                        <a:rPr lang="en-GB" b="1" dirty="0"/>
+                        <a:rPr lang="en-GB" b="1"/>
                         <a:t>GET, POST, HEAD</a:t>
                       </a:r>
                     </a:p>
@@ -10366,15 +10844,15 @@
                     <a:lstStyle/>
                     <a:p>
                       <a:r>
-                        <a:rPr lang="en-GB" dirty="0"/>
+                        <a:rPr lang="en-GB"/>
                         <a:t>/order/&lt;</a:t>
                       </a:r>
                       <a:r>
-                        <a:rPr lang="en-GB" dirty="0" err="1"/>
+                        <a:rPr lang="en-GB" err="1"/>
                         <a:t>orderNumber</a:t>
                       </a:r>
                       <a:r>
-                        <a:rPr lang="en-GB" dirty="0"/>
+                        <a:rPr lang="en-GB"/>
                         <a:t>&gt;</a:t>
                       </a:r>
                     </a:p>
@@ -10387,7 +10865,7 @@
                     <a:lstStyle/>
                     <a:p>
                       <a:r>
-                        <a:rPr lang="en-GB" dirty="0"/>
+                        <a:rPr lang="en-GB"/>
                         <a:t>GET, POST, PUT, DELETE</a:t>
                       </a:r>
                     </a:p>
@@ -10407,7 +10885,7 @@
                     <a:lstStyle/>
                     <a:p>
                       <a:r>
-                        <a:rPr lang="en-GB" dirty="0"/>
+                        <a:rPr lang="en-GB"/>
                         <a:t>…</a:t>
                       </a:r>
                     </a:p>
@@ -10420,7 +10898,7 @@
                     <a:lstStyle/>
                     <a:p>
                       <a:r>
-                        <a:rPr lang="en-GB" dirty="0"/>
+                        <a:rPr lang="en-GB"/>
                         <a:t>…</a:t>
                       </a:r>
                     </a:p>
@@ -10440,7 +10918,7 @@
                     <a:lstStyle/>
                     <a:p>
                       <a:r>
-                        <a:rPr lang="en-GB" dirty="0"/>
+                        <a:rPr lang="en-GB"/>
                         <a:t>…</a:t>
                       </a:r>
                     </a:p>
@@ -10453,7 +10931,7 @@
                     <a:lstStyle/>
                     <a:p>
                       <a:r>
-                        <a:rPr lang="en-GB" dirty="0"/>
+                        <a:rPr lang="en-GB"/>
                         <a:t>…</a:t>
                       </a:r>
                     </a:p>
@@ -10473,7 +10951,7 @@
                     <a:lstStyle/>
                     <a:p>
                       <a:r>
-                        <a:rPr lang="en-GB" dirty="0"/>
+                        <a:rPr lang="en-GB"/>
                         <a:t>…</a:t>
                       </a:r>
                     </a:p>
@@ -10486,7 +10964,7 @@
                     <a:lstStyle/>
                     <a:p>
                       <a:r>
-                        <a:rPr lang="en-GB" dirty="0"/>
+                        <a:rPr lang="en-GB"/>
                         <a:t>…</a:t>
                       </a:r>
                     </a:p>
@@ -10562,11 +11040,11 @@
           <a:lstStyle/>
           <a:p>
             <a:r>
-              <a:rPr lang="en-GB" dirty="0"/>
+              <a:rPr lang="en-GB"/>
               <a:t>Presenting Team Member: </a:t>
             </a:r>
             <a:r>
-              <a:rPr lang="en-GB" dirty="0">
+              <a:rPr lang="en-GB">
                 <a:solidFill>
                   <a:srgbClr val="FF0000"/>
                 </a:solidFill>
@@ -10639,7 +11117,7 @@
           <a:lstStyle/>
           <a:p>
             <a:r>
-              <a:rPr lang="en-GB" dirty="0"/>
+              <a:rPr lang="en-GB"/>
               <a:t>Web Service Implementation</a:t>
             </a:r>
           </a:p>
@@ -10669,7 +11147,7 @@
           <a:lstStyle/>
           <a:p>
             <a:r>
-              <a:rPr lang="en-GB" dirty="0">
+              <a:rPr lang="en-GB">
                 <a:solidFill>
                   <a:srgbClr val="FF0000"/>
                 </a:solidFill>
@@ -10679,7 +11157,7 @@
           </a:p>
           <a:p>
             <a:r>
-              <a:rPr lang="en-GB" dirty="0">
+              <a:rPr lang="en-GB">
                 <a:solidFill>
                   <a:srgbClr val="FF0000"/>
                 </a:solidFill>
@@ -10690,7 +11168,7 @@
           <a:p>
             <a:pPr lvl="1"/>
             <a:r>
-              <a:rPr lang="en-GB" dirty="0">
+              <a:rPr lang="en-GB">
                 <a:solidFill>
                   <a:srgbClr val="FF0000"/>
                 </a:solidFill>
@@ -10701,7 +11179,7 @@
           <a:p>
             <a:pPr lvl="1"/>
             <a:r>
-              <a:rPr lang="en-GB" dirty="0">
+              <a:rPr lang="en-GB">
                 <a:solidFill>
                   <a:srgbClr val="FF0000"/>
                 </a:solidFill>
@@ -10712,7 +11190,7 @@
           <a:p>
             <a:pPr lvl="2"/>
             <a:r>
-              <a:rPr lang="en-GB" dirty="0">
+              <a:rPr lang="en-GB">
                 <a:solidFill>
                   <a:srgbClr val="FF0000"/>
                 </a:solidFill>
@@ -10804,7 +11282,7 @@
                     <a:lstStyle/>
                     <a:p>
                       <a:r>
-                        <a:rPr lang="en-GB" dirty="0"/>
+                        <a:rPr lang="en-GB"/>
                         <a:t>Endpoint</a:t>
                       </a:r>
                     </a:p>
@@ -10817,7 +11295,7 @@
                     <a:lstStyle/>
                     <a:p>
                       <a:r>
-                        <a:rPr lang="en-GB" dirty="0"/>
+                        <a:rPr lang="en-GB"/>
                         <a:t>HTTP Method(s)</a:t>
                       </a:r>
                     </a:p>
@@ -10840,11 +11318,11 @@
                         <a:buNone/>
                       </a:pPr>
                       <a:r>
-                        <a:rPr lang="en-GB" dirty="0" err="1"/>
+                        <a:rPr lang="en-GB" err="1"/>
                         <a:t>api</a:t>
                       </a:r>
                       <a:r>
-                        <a:rPr lang="en-GB" dirty="0"/>
+                        <a:rPr lang="en-GB"/>
                         <a:t>/v1/users/login</a:t>
                       </a:r>
                     </a:p>
@@ -10857,7 +11335,7 @@
                     <a:lstStyle/>
                     <a:p>
                       <a:r>
-                        <a:rPr lang="en-GB" dirty="0"/>
+                        <a:rPr lang="en-GB"/>
                         <a:t>POST</a:t>
                       </a:r>
                     </a:p>
@@ -10877,13 +11355,13 @@
                     <a:lstStyle/>
                     <a:p>
                       <a:r>
-                        <a:rPr lang="en-GB" b="0" dirty="0" err="1">
+                        <a:rPr lang="en-GB" b="0" err="1">
                           <a:latin typeface="Calibri"/>
                         </a:rPr>
                         <a:t>api</a:t>
                       </a:r>
                       <a:r>
-                        <a:rPr lang="en-GB" b="0" dirty="0">
+                        <a:rPr lang="en-GB" b="0">
                           <a:latin typeface="Calibri"/>
                         </a:rPr>
                         <a:t>/v1/users/create</a:t>
@@ -10898,7 +11376,7 @@
                     <a:lstStyle/>
                     <a:p>
                       <a:r>
-                        <a:rPr lang="en-GB" b="0" dirty="0"/>
+                        <a:rPr lang="en-GB" b="0"/>
                         <a:t>POST</a:t>
                       </a:r>
                     </a:p>
@@ -10918,11 +11396,11 @@
                     <a:lstStyle/>
                     <a:p>
                       <a:r>
-                        <a:rPr lang="en-GB" dirty="0" err="1"/>
+                        <a:rPr lang="en-GB" err="1"/>
                         <a:t>api</a:t>
                       </a:r>
                       <a:r>
-                        <a:rPr lang="en-GB" dirty="0"/>
+                        <a:rPr lang="en-GB"/>
                         <a:t>/v1/interests</a:t>
                       </a:r>
                     </a:p>
@@ -10935,7 +11413,7 @@
                     <a:lstStyle/>
                     <a:p>
                       <a:r>
-                        <a:rPr lang="en-GB" dirty="0"/>
+                        <a:rPr lang="en-GB"/>
                         <a:t>GET</a:t>
                       </a:r>
                     </a:p>
@@ -10955,7 +11433,7 @@
                     <a:lstStyle/>
                     <a:p>
                       <a:r>
-                        <a:rPr lang="en-GB" dirty="0"/>
+                        <a:rPr lang="en-GB"/>
                         <a:t>Api/v1/users/&lt;id&gt;</a:t>
                       </a:r>
                     </a:p>
@@ -10968,7 +11446,7 @@
                     <a:lstStyle/>
                     <a:p>
                       <a:r>
-                        <a:rPr lang="en-GB" dirty="0"/>
+                        <a:rPr lang="en-GB"/>
                         <a:t>DELETE</a:t>
                       </a:r>
                     </a:p>
@@ -11044,10 +11522,10 @@
           <a:lstStyle/>
           <a:p>
             <a:r>
-              <a:rPr lang="en-GB" dirty="0"/>
+              <a:rPr lang="en-GB"/>
               <a:t>Presenting Team Member: Dan</a:t>
             </a:r>
-            <a:endParaRPr lang="en-GB" dirty="0">
+            <a:endParaRPr lang="en-GB">
               <a:solidFill>
                 <a:srgbClr val="FF0000"/>
               </a:solidFill>
@@ -11114,7 +11592,7 @@
           <a:lstStyle/>
           <a:p>
             <a:r>
-              <a:rPr lang="en-GB" dirty="0"/>
+              <a:rPr lang="en-GB"/>
               <a:t>Web Service Demo: Using Client frontend</a:t>
             </a:r>
           </a:p>
@@ -11147,7 +11625,7 @@
           <a:lstStyle/>
           <a:p>
             <a:r>
-              <a:rPr lang="en-GB" dirty="0">
+              <a:rPr lang="en-GB">
                 <a:solidFill>
                   <a:srgbClr val="FF0000"/>
                 </a:solidFill>
@@ -11239,22 +11717,22 @@
           <a:noFill/>
         </p:spPr>
         <p:txBody>
-          <a:bodyPr wrap="square">
+          <a:bodyPr wrap="square" lIns="91440" tIns="45720" rIns="91440" bIns="45720" anchor="t">
             <a:spAutoFit/>
           </a:bodyPr>
           <a:lstStyle/>
           <a:p>
             <a:r>
-              <a:rPr lang="en-GB" dirty="0"/>
+              <a:rPr lang="en-GB"/>
               <a:t>Presenting Team Member: </a:t>
             </a:r>
             <a:r>
-              <a:rPr lang="en-GB" dirty="0">
+              <a:rPr lang="en-GB">
                 <a:solidFill>
                   <a:srgbClr val="FF0000"/>
                 </a:solidFill>
               </a:rPr>
-              <a:t>Student 5</a:t>
+              <a:t>Zak</a:t>
             </a:r>
           </a:p>
         </p:txBody>
@@ -11318,7 +11796,7 @@
           <a:p>
             <a:pPr algn="ctr"/>
             <a:r>
-              <a:rPr lang="en-GB" dirty="0">
+              <a:rPr lang="en-GB">
                 <a:solidFill>
                   <a:srgbClr val="FF0000"/>
                 </a:solidFill>
@@ -11350,7 +11828,7 @@
           <a:lstStyle/>
           <a:p>
             <a:r>
-              <a:rPr lang="en-GB" dirty="0">
+              <a:rPr lang="en-GB">
                 <a:solidFill>
                   <a:srgbClr val="FF0000"/>
                 </a:solidFill>
@@ -11418,7 +11896,7 @@
           <a:lstStyle/>
           <a:p>
             <a:r>
-              <a:rPr lang="en-GB" dirty="0"/>
+              <a:rPr lang="en-GB"/>
               <a:t>System Evaluation and Reflection</a:t>
             </a:r>
           </a:p>
@@ -11446,7 +11924,7 @@
           <a:lstStyle/>
           <a:p>
             <a:r>
-              <a:rPr lang="en-GB" dirty="0">
+              <a:rPr lang="en-GB">
                 <a:solidFill>
                   <a:srgbClr val="FF0000"/>
                 </a:solidFill>
@@ -11514,11 +11992,11 @@
           <a:lstStyle/>
           <a:p>
             <a:r>
-              <a:rPr lang="en-GB" dirty="0"/>
+              <a:rPr lang="en-GB"/>
               <a:t>Presenting Team Member: </a:t>
             </a:r>
             <a:r>
-              <a:rPr lang="en-GB" dirty="0">
+              <a:rPr lang="en-GB">
                 <a:solidFill>
                   <a:srgbClr val="FF0000"/>
                 </a:solidFill>
@@ -11580,7 +12058,7 @@
           <a:lstStyle/>
           <a:p>
             <a:r>
-              <a:rPr lang="en-GB" dirty="0"/>
+              <a:rPr lang="en-GB"/>
               <a:t>System Evaluation and Reflection</a:t>
             </a:r>
           </a:p>
@@ -11608,7 +12086,7 @@
           <a:lstStyle/>
           <a:p>
             <a:r>
-              <a:rPr lang="en-GB" dirty="0">
+              <a:rPr lang="en-GB">
                 <a:solidFill>
                   <a:srgbClr val="FF0000"/>
                 </a:solidFill>
@@ -11619,7 +12097,7 @@
           <a:p>
             <a:pPr lvl="1"/>
             <a:r>
-              <a:rPr lang="en-GB" dirty="0">
+              <a:rPr lang="en-GB">
                 <a:solidFill>
                   <a:srgbClr val="FF0000"/>
                 </a:solidFill>
@@ -11630,7 +12108,7 @@
           <a:p>
             <a:pPr lvl="1"/>
             <a:r>
-              <a:rPr lang="en-GB" dirty="0">
+              <a:rPr lang="en-GB">
                 <a:solidFill>
                   <a:srgbClr val="FF0000"/>
                 </a:solidFill>
@@ -11641,7 +12119,7 @@
           <a:p>
             <a:pPr lvl="1"/>
             <a:r>
-              <a:rPr lang="en-GB" dirty="0">
+              <a:rPr lang="en-GB">
                 <a:solidFill>
                   <a:srgbClr val="FF0000"/>
                 </a:solidFill>
@@ -11652,7 +12130,7 @@
           <a:p>
             <a:pPr lvl="2"/>
             <a:r>
-              <a:rPr lang="en-GB" dirty="0">
+              <a:rPr lang="en-GB">
                 <a:solidFill>
                   <a:srgbClr val="FF0000"/>
                 </a:solidFill>
@@ -11663,7 +12141,7 @@
           <a:p>
             <a:pPr lvl="2"/>
             <a:r>
-              <a:rPr lang="en-GB" dirty="0">
+              <a:rPr lang="en-GB">
                 <a:solidFill>
                   <a:srgbClr val="FF0000"/>
                 </a:solidFill>
@@ -11674,7 +12152,7 @@
           <a:p>
             <a:pPr lvl="1"/>
             <a:r>
-              <a:rPr lang="en-GB" dirty="0">
+              <a:rPr lang="en-GB">
                 <a:solidFill>
                   <a:srgbClr val="FF0000"/>
                 </a:solidFill>
@@ -11742,11 +12220,11 @@
           <a:lstStyle/>
           <a:p>
             <a:r>
-              <a:rPr lang="en-GB" dirty="0"/>
+              <a:rPr lang="en-GB"/>
               <a:t>Presenting Team Member(s): </a:t>
             </a:r>
             <a:r>
-              <a:rPr lang="en-GB" dirty="0">
+              <a:rPr lang="en-GB">
                 <a:solidFill>
                   <a:srgbClr val="FF0000"/>
                 </a:solidFill>
@@ -11808,7 +12286,7 @@
           <a:lstStyle/>
           <a:p>
             <a:r>
-              <a:rPr lang="en-GB" dirty="0">
+              <a:rPr lang="en-GB">
                 <a:solidFill>
                   <a:srgbClr val="FF0000"/>
                 </a:solidFill>
@@ -11840,7 +12318,7 @@
           <a:lstStyle/>
           <a:p>
             <a:r>
-              <a:rPr lang="en-GB" dirty="0">
+              <a:rPr lang="en-GB">
                 <a:solidFill>
                   <a:srgbClr val="FF0000"/>
                 </a:solidFill>
@@ -11849,7 +12327,7 @@
             </a:r>
           </a:p>
           <a:p>
-            <a:endParaRPr lang="en-GB" dirty="0"/>
+            <a:endParaRPr lang="en-GB"/>
           </a:p>
         </p:txBody>
       </p:sp>
@@ -11935,18 +12413,9 @@
           <a:p>
             <a:pPr algn="ctr"/>
             <a:r>
-              <a:rPr lang="en-GB">
-                <a:solidFill>
-                  <a:srgbClr val="FF0000"/>
-                </a:solidFill>
-              </a:rPr>
+              <a:rPr lang="en-GB"/>
               <a:t>University Society Recommendation System</a:t>
             </a:r>
-            <a:endParaRPr lang="en-GB" dirty="0">
-              <a:solidFill>
-                <a:srgbClr val="FF0000"/>
-              </a:solidFill>
-            </a:endParaRPr>
           </a:p>
         </p:txBody>
       </p:sp>
@@ -11980,7 +12449,7 @@
           <a:p>
             <a:pPr algn="ctr"/>
             <a:r>
-              <a:rPr lang="en-GB" sz="1800" dirty="0">
+              <a:rPr lang="en-GB" sz="1800">
                 <a:solidFill>
                   <a:srgbClr val="000000"/>
                 </a:solidFill>
@@ -11993,7 +12462,7 @@
               <a:t>A society recommendation system based on shared communities (LGBTQ+ / Identity), Interests (Gaming, Cyber Security</a:t>
             </a:r>
             <a:r>
-              <a:rPr lang="en-GB" sz="1800" dirty="0">
+              <a:rPr lang="en-GB" sz="1800">
                 <a:solidFill>
                   <a:srgbClr val="000000"/>
                 </a:solidFill>
@@ -12006,7 +12475,7 @@
               <a:t>),</a:t>
             </a:r>
             <a:r>
-              <a:rPr lang="en-GB" sz="1800" dirty="0">
+              <a:rPr lang="en-GB" sz="1800">
                 <a:solidFill>
                   <a:srgbClr val="000000"/>
                 </a:solidFill>
@@ -12105,7 +12574,7 @@
           <a:p>
             <a:pPr algn="ctr"/>
             <a:r>
-              <a:rPr lang="en-GB" dirty="0">
+              <a:rPr lang="en-GB">
                 <a:solidFill>
                   <a:srgbClr val="FF0000"/>
                 </a:solidFill>
@@ -12137,7 +12606,7 @@
           <a:lstStyle/>
           <a:p>
             <a:r>
-              <a:rPr lang="en-GB" dirty="0">
+              <a:rPr lang="en-GB">
                 <a:solidFill>
                   <a:srgbClr val="FF0000"/>
                 </a:solidFill>
@@ -12240,7 +12709,7 @@
             <a:pPr lvl="0">
               <a:defRPr/>
             </a:pPr>
-            <a:endParaRPr lang="en-GB" sz="3200" b="1" dirty="0">
+            <a:endParaRPr lang="en-GB" sz="3200" b="1">
               <a:solidFill>
                 <a:srgbClr val="002060"/>
               </a:solidFill>
@@ -12378,7 +12847,7 @@
           <a:lstStyle/>
           <a:p>
             <a:r>
-              <a:rPr lang="en-GB" dirty="0"/>
+              <a:rPr lang="en-GB"/>
               <a:t>Elevator Pitch: Project Idea Summary</a:t>
             </a:r>
           </a:p>
@@ -12413,12 +12882,8 @@
           <a:lstStyle/>
           <a:p>
             <a:r>
-              <a:rPr lang="en-GB" dirty="0"/>
-              <a:t>Presenting Team Member: </a:t>
-            </a:r>
-            <a:r>
               <a:rPr lang="en-GB"/>
-              <a:t>Alex</a:t>
+              <a:t>Presenting Team Member: Alex</a:t>
             </a:r>
             <a:endParaRPr lang="en-GB">
               <a:ea typeface="Calibri"/>
@@ -12596,7 +13061,7 @@
           <a:lstStyle/>
           <a:p>
             <a:r>
-              <a:rPr lang="en-GB" dirty="0"/>
+              <a:rPr lang="en-GB"/>
               <a:t>Features Identified</a:t>
             </a:r>
           </a:p>
@@ -12624,7 +13089,7 @@
           <a:lstStyle/>
           <a:p>
             <a:r>
-              <a:rPr lang="en-GB" dirty="0">
+              <a:rPr lang="en-GB">
                 <a:solidFill>
                   <a:srgbClr val="FF0000"/>
                 </a:solidFill>
@@ -12633,10 +13098,10 @@
             </a:r>
           </a:p>
           <a:p>
-            <a:endParaRPr lang="en-GB" dirty="0"/>
-          </a:p>
-          <a:p>
-            <a:endParaRPr lang="en-GB" dirty="0"/>
+            <a:endParaRPr lang="en-GB"/>
+          </a:p>
+          <a:p>
+            <a:endParaRPr lang="en-GB"/>
           </a:p>
         </p:txBody>
       </p:sp>
@@ -12736,7 +13201,7 @@
                     <a:lstStyle/>
                     <a:p>
                       <a:r>
-                        <a:rPr lang="en-GB" dirty="0"/>
+                        <a:rPr lang="en-GB"/>
                         <a:t>Feature</a:t>
                       </a:r>
                     </a:p>
@@ -12749,7 +13214,7 @@
                     <a:lstStyle/>
                     <a:p>
                       <a:r>
-                        <a:rPr lang="en-GB" dirty="0"/>
+                        <a:rPr lang="en-GB"/>
                         <a:t>Description</a:t>
                       </a:r>
                     </a:p>
@@ -12762,7 +13227,7 @@
                     <a:lstStyle/>
                     <a:p>
                       <a:r>
-                        <a:rPr lang="en-GB" dirty="0"/>
+                        <a:rPr lang="en-GB"/>
                         <a:t>Stakeholder(s) involved</a:t>
                       </a:r>
                     </a:p>
@@ -12775,7 +13240,7 @@
                     <a:lstStyle/>
                     <a:p>
                       <a:r>
-                        <a:rPr lang="en-GB" dirty="0"/>
+                        <a:rPr lang="en-GB"/>
                         <a:t>Importance</a:t>
                       </a:r>
                     </a:p>
@@ -12794,7 +13259,7 @@
                     <a:bodyPr/>
                     <a:lstStyle/>
                     <a:p>
-                      <a:endParaRPr lang="en-GB" dirty="0"/>
+                      <a:endParaRPr lang="en-GB"/>
                     </a:p>
                   </a:txBody>
                   <a:tcPr/>
@@ -12908,7 +13373,7 @@
                     <a:bodyPr/>
                     <a:lstStyle/>
                     <a:p>
-                      <a:endParaRPr lang="en-GB" dirty="0"/>
+                      <a:endParaRPr lang="en-GB"/>
                     </a:p>
                   </a:txBody>
                   <a:tcPr/>
@@ -12918,7 +13383,7 @@
                     <a:bodyPr/>
                     <a:lstStyle/>
                     <a:p>
-                      <a:endParaRPr lang="en-GB" dirty="0"/>
+                      <a:endParaRPr lang="en-GB"/>
                     </a:p>
                   </a:txBody>
                   <a:tcPr/>
@@ -12962,16 +13427,8 @@
           <a:lstStyle/>
           <a:p>
             <a:r>
-              <a:rPr lang="en-GB" dirty="0"/>
+              <a:rPr lang="en-GB"/>
               <a:t>Presenting Team Member: </a:t>
-            </a:r>
-            <a:r>
-              <a:rPr lang="en-GB" dirty="0">
-                <a:solidFill>
-                  <a:srgbClr val="FF0000"/>
-                </a:solidFill>
-              </a:rPr>
-              <a:t>Student </a:t>
             </a:r>
             <a:r>
               <a:rPr lang="en-GB">
@@ -12979,13 +13436,8 @@
                   <a:srgbClr val="FF0000"/>
                 </a:solidFill>
               </a:rPr>
-              <a:t>4</a:t>
-            </a:r>
-            <a:endParaRPr lang="en-GB" dirty="0">
-              <a:solidFill>
-                <a:srgbClr val="FF0000"/>
-              </a:solidFill>
-            </a:endParaRPr>
+              <a:t>Student 4</a:t>
+            </a:r>
           </a:p>
         </p:txBody>
       </p:sp>
@@ -13118,7 +13570,7 @@
             <a:pPr lvl="0">
               <a:defRPr/>
             </a:pPr>
-            <a:endParaRPr lang="en-GB" sz="3200" b="1" dirty="0">
+            <a:endParaRPr lang="en-GB" sz="3200" b="1">
               <a:solidFill>
                 <a:srgbClr val="002060"/>
               </a:solidFill>
@@ -13148,7 +13600,7 @@
           <a:lstStyle/>
           <a:p>
             <a:r>
-              <a:rPr lang="en-GB" dirty="0"/>
+              <a:rPr lang="en-GB"/>
               <a:t>Tech Stack</a:t>
             </a:r>
           </a:p>
@@ -13183,10 +13635,10 @@
           <a:lstStyle/>
           <a:p>
             <a:r>
-              <a:rPr lang="en-GB" dirty="0"/>
+              <a:rPr lang="en-GB"/>
               <a:t>Presenting Team Member: Dan</a:t>
             </a:r>
-            <a:endParaRPr lang="en-GB" dirty="0">
+            <a:endParaRPr lang="en-GB">
               <a:solidFill>
                 <a:srgbClr val="FF0000"/>
               </a:solidFill>
@@ -13194,36 +13646,38 @@
           </a:p>
         </p:txBody>
       </p:sp>
-      <p:sp>
-        <p:nvSpPr>
-          <p:cNvPr id="4" name="Content Placeholder 3">
+      <p:pic>
+        <p:nvPicPr>
+          <p:cNvPr id="3" name="Content Placeholder 2" descr="A screenshot of a computer&#10;&#10;AI-generated content may be incorrect.">
             <a:extLst>
               <a:ext uri="{FF2B5EF4-FFF2-40B4-BE49-F238E27FC236}">
-                <a16:creationId xmlns:a16="http://schemas.microsoft.com/office/drawing/2014/main" id="{CBC1F614-8B20-1750-A035-9E5EE81F1E9D}"/>
+                <a16:creationId xmlns:a16="http://schemas.microsoft.com/office/drawing/2014/main" id="{B80EF2E0-CF9F-DDA4-EDD5-5DE343A0FFC1}"/>
               </a:ext>
             </a:extLst>
           </p:cNvPr>
-          <p:cNvSpPr>
-            <a:spLocks noGrp="1"/>
-          </p:cNvSpPr>
+          <p:cNvPicPr>
+            <a:picLocks noGrp="1" noChangeAspect="1"/>
+          </p:cNvPicPr>
           <p:nvPr>
             <p:ph sz="half" idx="2"/>
           </p:nvPr>
-        </p:nvSpPr>
+        </p:nvPicPr>
+        <p:blipFill>
+          <a:blip r:embed="rId5"/>
+          <a:stretch>
+            <a:fillRect/>
+          </a:stretch>
+        </p:blipFill>
         <p:spPr>
           <a:xfrm>
-            <a:off x="1165671" y="1825625"/>
-            <a:ext cx="7713203" cy="3186297"/>
+            <a:off x="1192401" y="1825625"/>
+            <a:ext cx="10128371" cy="4206495"/>
           </a:xfrm>
+          <a:prstGeom prst="rect">
+            <a:avLst/>
+          </a:prstGeom>
         </p:spPr>
-        <p:txBody>
-          <a:bodyPr/>
-          <a:lstStyle/>
-          <a:p>
-            <a:endParaRPr lang="en-GB"/>
-          </a:p>
-        </p:txBody>
-      </p:sp>
+      </p:pic>
     </p:spTree>
     <p:extLst>
       <p:ext uri="{BB962C8B-B14F-4D97-AF65-F5344CB8AC3E}">
@@ -13290,7 +13744,7 @@
           <a:p>
             <a:pPr algn="ctr"/>
             <a:r>
-              <a:rPr lang="en-GB" dirty="0">
+              <a:rPr lang="en-GB">
                 <a:solidFill>
                   <a:srgbClr val="FF0000"/>
                 </a:solidFill>
@@ -13298,14 +13752,14 @@
               <a:t>Database </a:t>
             </a:r>
             <a:br>
-              <a:rPr lang="en-GB" dirty="0">
+              <a:rPr lang="en-GB">
                 <a:solidFill>
                   <a:srgbClr val="FF0000"/>
                 </a:solidFill>
               </a:rPr>
             </a:br>
             <a:r>
-              <a:rPr lang="en-GB" dirty="0">
+              <a:rPr lang="en-GB">
                 <a:solidFill>
                   <a:srgbClr val="FF0000"/>
                 </a:solidFill>
@@ -13337,7 +13791,7 @@
           <a:lstStyle/>
           <a:p>
             <a:r>
-              <a:rPr lang="en-GB" dirty="0">
+              <a:rPr lang="en-GB">
                 <a:solidFill>
                   <a:srgbClr val="FF0000"/>
                 </a:solidFill>
@@ -13399,7 +13853,7 @@
           <a:lstStyle/>
           <a:p>
             <a:r>
-              <a:rPr lang="en-GB" dirty="0"/>
+              <a:rPr lang="en-GB"/>
               <a:t>Database Design</a:t>
             </a:r>
           </a:p>
@@ -13434,55 +13888,6 @@
           </a:p>
         </p:txBody>
       </p:sp>
-      <p:pic>
-        <p:nvPicPr>
-          <p:cNvPr id="2050" name="Picture 2">
-            <a:extLst>
-              <a:ext uri="{FF2B5EF4-FFF2-40B4-BE49-F238E27FC236}">
-                <a16:creationId xmlns:a16="http://schemas.microsoft.com/office/drawing/2014/main" id="{5E51E38A-E7B1-5FDA-E9F3-DF53D3CA2316}"/>
-              </a:ext>
-            </a:extLst>
-          </p:cNvPr>
-          <p:cNvPicPr>
-            <a:picLocks noGrp="1" noChangeAspect="1" noChangeArrowheads="1"/>
-          </p:cNvPicPr>
-          <p:nvPr>
-            <p:ph idx="1"/>
-          </p:nvPr>
-        </p:nvPicPr>
-        <p:blipFill>
-          <a:blip r:embed="rId4">
-            <a:extLst>
-              <a:ext uri="{28A0092B-C50C-407E-A947-70E740481C1C}">
-                <a14:useLocalDpi xmlns:a14="http://schemas.microsoft.com/office/drawing/2010/main" val="0"/>
-              </a:ext>
-            </a:extLst>
-          </a:blip>
-          <a:srcRect/>
-          <a:stretch>
-            <a:fillRect/>
-          </a:stretch>
-        </p:blipFill>
-        <p:spPr bwMode="auto">
-          <a:xfrm>
-            <a:off x="3238500" y="2043906"/>
-            <a:ext cx="5715000" cy="3914775"/>
-          </a:xfrm>
-          <a:prstGeom prst="rect">
-            <a:avLst/>
-          </a:prstGeom>
-          <a:noFill/>
-          <a:extLst>
-            <a:ext uri="{909E8E84-426E-40DD-AFC4-6F175D3DCCD1}">
-              <a14:hiddenFill xmlns:a14="http://schemas.microsoft.com/office/drawing/2010/main">
-                <a:solidFill>
-                  <a:srgbClr val="FFFFFF"/>
-                </a:solidFill>
-              </a14:hiddenFill>
-            </a:ext>
-          </a:extLst>
-        </p:spPr>
-      </p:pic>
       <p:sp>
         <p:nvSpPr>
           <p:cNvPr id="12" name="TextBox 11">
@@ -13506,23 +13911,22 @@
           <a:noFill/>
         </p:spPr>
         <p:txBody>
-          <a:bodyPr wrap="square" rtlCol="0">
+          <a:bodyPr wrap="square" lIns="91440" tIns="45720" rIns="91440" bIns="45720" rtlCol="0" anchor="t">
             <a:spAutoFit/>
           </a:bodyPr>
           <a:lstStyle/>
           <a:p>
             <a:r>
-              <a:rPr lang="en-GB" dirty="0"/>
-              <a:t>Presenting Team Member: </a:t>
-            </a:r>
-            <a:r>
-              <a:rPr lang="en-GB" dirty="0">
-                <a:solidFill>
-                  <a:srgbClr val="FF0000"/>
-                </a:solidFill>
-              </a:rPr>
-              <a:t>Student 3</a:t>
-            </a:r>
+              <a:rPr lang="en-GB"/>
+              <a:t>Presenting Team Member: Abraham</a:t>
+            </a:r>
+            <a:endParaRPr lang="en-GB">
+              <a:solidFill>
+                <a:srgbClr val="FF0000"/>
+              </a:solidFill>
+              <a:ea typeface="Calibri"/>
+              <a:cs typeface="Calibri"/>
+            </a:endParaRPr>
           </a:p>
         </p:txBody>
       </p:sp>
@@ -13541,7 +13945,7 @@
           <p:nvPr/>
         </p:nvPicPr>
         <p:blipFill>
-          <a:blip r:embed="rId5"/>
+          <a:blip r:embed="rId4"/>
           <a:stretch>
             <a:fillRect/>
           </a:stretch>
@@ -13595,12 +13999,42 @@
           </a:fontRef>
         </p:style>
       </p:cxnSp>
-      <p:sp>
-        <p:nvSpPr>
-          <p:cNvPr id="6" name="TextBox 5">
+      <p:pic>
+        <p:nvPicPr>
+          <p:cNvPr id="3" name="Picture 2" descr="A diagram of a community&#10;&#10;AI-generated content may be incorrect.">
             <a:extLst>
               <a:ext uri="{FF2B5EF4-FFF2-40B4-BE49-F238E27FC236}">
-                <a16:creationId xmlns:a16="http://schemas.microsoft.com/office/drawing/2014/main" id="{80DAC7C5-DDE2-5FBC-4D1F-608903D10721}"/>
+                <a16:creationId xmlns:a16="http://schemas.microsoft.com/office/drawing/2014/main" id="{3897E974-C7F8-C54E-A93E-009ADC7E2359}"/>
+              </a:ext>
+            </a:extLst>
+          </p:cNvPr>
+          <p:cNvPicPr>
+            <a:picLocks noChangeAspect="1"/>
+          </p:cNvPicPr>
+          <p:nvPr/>
+        </p:nvPicPr>
+        <p:blipFill>
+          <a:blip r:embed="rId5"/>
+          <a:stretch>
+            <a:fillRect/>
+          </a:stretch>
+        </p:blipFill>
+        <p:spPr>
+          <a:xfrm>
+            <a:off x="615203" y="1827679"/>
+            <a:ext cx="7353302" cy="4356848"/>
+          </a:xfrm>
+          <a:prstGeom prst="rect">
+            <a:avLst/>
+          </a:prstGeom>
+        </p:spPr>
+      </p:pic>
+      <p:sp>
+        <p:nvSpPr>
+          <p:cNvPr id="7" name="TextBox 6">
+            <a:extLst>
+              <a:ext uri="{FF2B5EF4-FFF2-40B4-BE49-F238E27FC236}">
+                <a16:creationId xmlns:a16="http://schemas.microsoft.com/office/drawing/2014/main" id="{B2D8061A-7D04-0CCE-BFF4-2FDC9C3D156F}"/>
               </a:ext>
             </a:extLst>
           </p:cNvPr>
@@ -13609,8 +14043,8 @@
         </p:nvSpPr>
         <p:spPr>
           <a:xfrm>
-            <a:off x="8402595" y="2508422"/>
-            <a:ext cx="3825343" cy="369332"/>
+            <a:off x="8059913" y="1683749"/>
+            <a:ext cx="3974751" cy="4524315"/>
           </a:xfrm>
           <a:prstGeom prst="rect">
             <a:avLst/>
@@ -13618,19 +14052,86 @@
           <a:noFill/>
         </p:spPr>
         <p:txBody>
-          <a:bodyPr wrap="none" rtlCol="0">
+          <a:bodyPr rot="0" spcFirstLastPara="0" vertOverflow="overflow" horzOverflow="overflow" vert="horz" wrap="square" lIns="91440" tIns="45720" rIns="91440" bIns="45720" numCol="1" spcCol="0" rtlCol="0" fromWordArt="0" anchor="t" anchorCtr="0" forceAA="0" compatLnSpc="1">
+            <a:prstTxWarp prst="textNoShape">
+              <a:avLst/>
+            </a:prstTxWarp>
             <a:spAutoFit/>
           </a:bodyPr>
           <a:lstStyle/>
           <a:p>
             <a:r>
-              <a:rPr lang="en-GB" dirty="0">
-                <a:solidFill>
-                  <a:srgbClr val="FF0000"/>
-                </a:solidFill>
+              <a:rPr lang="en-GB" sz="2400">
+                <a:ea typeface="+mn-lt"/>
+                <a:cs typeface="+mn-lt"/>
               </a:rPr>
-              <a:t>Make sure to name each relationship!</a:t>
-            </a:r>
+              <a:t>The physical ERD shows the implemented relational database for the Society Recommendation System. </a:t>
+            </a:r>
+            <a:endParaRPr lang="en-US" sz="2400">
+              <a:ea typeface="+mn-lt"/>
+              <a:cs typeface="+mn-lt"/>
+            </a:endParaRPr>
+          </a:p>
+          <a:p>
+            <a:endParaRPr lang="en-GB" sz="2400">
+              <a:ea typeface="+mn-lt"/>
+              <a:cs typeface="+mn-lt"/>
+            </a:endParaRPr>
+          </a:p>
+          <a:p>
+            <a:r>
+              <a:rPr lang="en-GB" sz="2400">
+                <a:ea typeface="+mn-lt"/>
+                <a:cs typeface="+mn-lt"/>
+              </a:rPr>
+              <a:t>It uses </a:t>
+            </a:r>
+            <a:r>
+              <a:rPr lang="en-GB" sz="2400" b="1">
+                <a:ea typeface="+mn-lt"/>
+                <a:cs typeface="+mn-lt"/>
+              </a:rPr>
+              <a:t>one-to-many</a:t>
+            </a:r>
+            <a:r>
+              <a:rPr lang="en-GB" sz="2400">
+                <a:ea typeface="+mn-lt"/>
+                <a:cs typeface="+mn-lt"/>
+              </a:rPr>
+              <a:t> and </a:t>
+            </a:r>
+            <a:r>
+              <a:rPr lang="en-GB" sz="2400" b="1">
+                <a:ea typeface="+mn-lt"/>
+                <a:cs typeface="+mn-lt"/>
+              </a:rPr>
+              <a:t>many-to-many</a:t>
+            </a:r>
+            <a:r>
+              <a:rPr lang="en-GB" sz="2400">
+                <a:ea typeface="+mn-lt"/>
+                <a:cs typeface="+mn-lt"/>
+              </a:rPr>
+              <a:t> relationships, with </a:t>
+            </a:r>
+            <a:r>
+              <a:rPr lang="en-GB" sz="2400" b="1">
+                <a:ea typeface="+mn-lt"/>
+                <a:cs typeface="+mn-lt"/>
+              </a:rPr>
+              <a:t>association tables</a:t>
+            </a:r>
+            <a:r>
+              <a:rPr lang="en-GB" sz="2400">
+                <a:ea typeface="+mn-lt"/>
+                <a:cs typeface="+mn-lt"/>
+              </a:rPr>
+              <a:t> to ensure data integrity, normalisation, and support for personalised recommendations.</a:t>
+            </a:r>
+            <a:endParaRPr lang="en-US" sz="2400">
+              <a:ea typeface="Calibri"/>
+              <a:cs typeface="Calibri"/>
+            </a:endParaRPr>
           </a:p>
         </p:txBody>
       </p:sp>
@@ -13697,7 +14198,7 @@
           <a:lstStyle/>
           <a:p>
             <a:r>
-              <a:rPr lang="en-GB" dirty="0"/>
+              <a:rPr lang="en-GB"/>
               <a:t>Database Implementation</a:t>
             </a:r>
           </a:p>
@@ -13726,7 +14227,7 @@
           </a:bodyPr>
           <a:lstStyle/>
           <a:p>
-            <a:endParaRPr lang="en-GB" dirty="0"/>
+            <a:endParaRPr lang="en-GB"/>
           </a:p>
         </p:txBody>
       </p:sp>
@@ -13754,7 +14255,7 @@
           <a:lstStyle/>
           <a:p>
             <a:r>
-              <a:rPr lang="en-GB" dirty="0">
+              <a:rPr lang="en-GB">
                 <a:solidFill>
                   <a:srgbClr val="FF0000"/>
                 </a:solidFill>
@@ -13764,7 +14265,7 @@
           </a:p>
           <a:p>
             <a:r>
-              <a:rPr lang="en-GB" dirty="0">
+              <a:rPr lang="en-GB">
                 <a:solidFill>
                   <a:srgbClr val="FF0000"/>
                 </a:solidFill>
@@ -13775,7 +14276,7 @@
           <a:p>
             <a:pPr lvl="1"/>
             <a:r>
-              <a:rPr lang="en-GB" dirty="0">
+              <a:rPr lang="en-GB">
                 <a:solidFill>
                   <a:srgbClr val="FF0000"/>
                 </a:solidFill>
@@ -13786,7 +14287,7 @@
           <a:p>
             <a:pPr lvl="1"/>
             <a:r>
-              <a:rPr lang="en-GB" dirty="0">
+              <a:rPr lang="en-GB">
                 <a:solidFill>
                   <a:srgbClr val="FF0000"/>
                 </a:solidFill>
@@ -13797,7 +14298,7 @@
           <a:p>
             <a:pPr lvl="2"/>
             <a:r>
-              <a:rPr lang="en-GB" dirty="0">
+              <a:rPr lang="en-GB">
                 <a:solidFill>
                   <a:srgbClr val="FF0000"/>
                 </a:solidFill>
@@ -13865,10 +14366,10 @@
           <a:lstStyle/>
           <a:p>
             <a:r>
-              <a:rPr lang="en-GB" dirty="0"/>
+              <a:rPr lang="en-GB"/>
               <a:t>Presenting Team Member: Dan</a:t>
             </a:r>
-            <a:endParaRPr lang="en-GB" dirty="0">
+            <a:endParaRPr lang="en-GB">
               <a:solidFill>
                 <a:srgbClr val="FF0000"/>
               </a:solidFill>
@@ -14757,12 +15258,6 @@
 </file>
 
 <file path=customXml/item1.xml><?xml version="1.0" encoding="utf-8"?>
-<p:properties xmlns:p="http://schemas.microsoft.com/office/2006/metadata/properties" xmlns:xsi="http://www.w3.org/2001/XMLSchema-instance" xmlns:pc="http://schemas.microsoft.com/office/infopath/2007/PartnerControls">
-  <documentManagement/>
-</p:properties>
-</file>
-
-<file path=customXml/item2.xml><?xml version="1.0" encoding="utf-8"?>
 <ct:contentTypeSchema xmlns:ct="http://schemas.microsoft.com/office/2006/metadata/contentType" xmlns:ma="http://schemas.microsoft.com/office/2006/metadata/properties/metaAttributes" ct:_="" ma:_="" ma:contentTypeName="Document" ma:contentTypeID="0x0101003FD13977575EAA4E8F9C11906492FC69" ma:contentTypeVersion="11" ma:contentTypeDescription="Create a new document." ma:contentTypeScope="" ma:versionID="e9ed61061286039959722191b07f9e0c">
   <xsd:schema xmlns:xsd="http://www.w3.org/2001/XMLSchema" xmlns:xs="http://www.w3.org/2001/XMLSchema" xmlns:p="http://schemas.microsoft.com/office/2006/metadata/properties" xmlns:ns3="a308fb6d-2bca-44a8-b40e-7c117ee46bdd" xmlns:ns4="1066959d-08e3-403d-b5ad-48f659ef38e8" targetNamespace="http://schemas.microsoft.com/office/2006/metadata/properties" ma:root="true" ma:fieldsID="49d83b0be8a84ad06eb2e61c1ba1b1e8" ns3:_="" ns4:_="">
     <xsd:import namespace="a308fb6d-2bca-44a8-b40e-7c117ee46bdd"/>
@@ -14973,7 +15468,7 @@
 </ct:contentTypeSchema>
 </file>
 
-<file path=customXml/item3.xml><?xml version="1.0" encoding="utf-8"?>
+<file path=customXml/item2.xml><?xml version="1.0" encoding="utf-8"?>
 <?mso-contentType ?>
 <FormTemplates xmlns="http://schemas.microsoft.com/sharepoint/v3/contenttype/forms">
   <Display>DocumentLibraryForm</Display>
@@ -14982,46 +15477,52 @@
 </FormTemplates>
 </file>
 
+<file path=customXml/item3.xml><?xml version="1.0" encoding="utf-8"?>
+<p:properties xmlns:p="http://schemas.microsoft.com/office/2006/metadata/properties" xmlns:xsi="http://www.w3.org/2001/XMLSchema-instance" xmlns:pc="http://schemas.microsoft.com/office/infopath/2007/PartnerControls">
+  <documentManagement/>
+</p:properties>
+</file>
+
 <file path=customXml/itemProps1.xml><?xml version="1.0" encoding="utf-8"?>
-<ds:datastoreItem xmlns:ds="http://schemas.openxmlformats.org/officeDocument/2006/customXml" ds:itemID="{4981EEB9-8C3F-42F4-B1EC-83A9AA22EC9C}">
+<ds:datastoreItem xmlns:ds="http://schemas.openxmlformats.org/officeDocument/2006/customXml" ds:itemID="{846E5FAD-5BF7-42F1-B568-ADDB179D94BB}">
   <ds:schemaRefs>
     <ds:schemaRef ds:uri="1066959d-08e3-403d-b5ad-48f659ef38e8"/>
-    <ds:schemaRef ds:uri="http://www.w3.org/XML/1998/namespace"/>
+    <ds:schemaRef ds:uri="a308fb6d-2bca-44a8-b40e-7c117ee46bdd"/>
+    <ds:schemaRef ds:uri="http://purl.org/dc/elements/1.1/"/>
+    <ds:schemaRef ds:uri="http://purl.org/dc/terms/"/>
+    <ds:schemaRef ds:uri="http://schemas.microsoft.com/internal/obd"/>
+    <ds:schemaRef ds:uri="http://schemas.microsoft.com/office/2006/documentManagement/types"/>
+    <ds:schemaRef ds:uri="http://schemas.microsoft.com/office/2006/metadata/contentType"/>
     <ds:schemaRef ds:uri="http://schemas.microsoft.com/office/2006/metadata/properties"/>
-    <ds:schemaRef ds:uri="http://schemas.microsoft.com/office/2006/documentManagement/types"/>
+    <ds:schemaRef ds:uri="http://schemas.microsoft.com/office/2006/metadata/properties/metaAttributes"/>
+    <ds:schemaRef ds:uri="http://schemas.microsoft.com/office/infopath/2007/PartnerControls"/>
     <ds:schemaRef ds:uri="http://schemas.openxmlformats.org/package/2006/metadata/core-properties"/>
-    <ds:schemaRef ds:uri="http://schemas.microsoft.com/office/infopath/2007/PartnerControls"/>
-    <ds:schemaRef ds:uri="a308fb6d-2bca-44a8-b40e-7c117ee46bdd"/>
-    <ds:schemaRef ds:uri="http://purl.org/dc/terms/"/>
-    <ds:schemaRef ds:uri="http://purl.org/dc/dcmitype/"/>
-    <ds:schemaRef ds:uri="http://purl.org/dc/elements/1.1/"/>
+    <ds:schemaRef ds:uri="http://www.w3.org/2001/XMLSchema"/>
   </ds:schemaRefs>
 </ds:datastoreItem>
 </file>
 
 <file path=customXml/itemProps2.xml><?xml version="1.0" encoding="utf-8"?>
-<ds:datastoreItem xmlns:ds="http://schemas.openxmlformats.org/officeDocument/2006/customXml" ds:itemID="{846E5FAD-5BF7-42F1-B568-ADDB179D94BB}">
+<ds:datastoreItem xmlns:ds="http://schemas.openxmlformats.org/officeDocument/2006/customXml" ds:itemID="{728F1355-E686-4225-B84F-21550D82A764}">
   <ds:schemaRefs>
-    <ds:schemaRef ds:uri="http://schemas.microsoft.com/office/2006/metadata/contentType"/>
-    <ds:schemaRef ds:uri="http://schemas.microsoft.com/office/2006/metadata/properties/metaAttributes"/>
-    <ds:schemaRef ds:uri="http://www.w3.org/2001/XMLSchema"/>
-    <ds:schemaRef ds:uri="http://schemas.microsoft.com/office/2006/metadata/properties"/>
-    <ds:schemaRef ds:uri="a308fb6d-2bca-44a8-b40e-7c117ee46bdd"/>
-    <ds:schemaRef ds:uri="1066959d-08e3-403d-b5ad-48f659ef38e8"/>
-    <ds:schemaRef ds:uri="http://schemas.microsoft.com/office/2006/documentManagement/types"/>
-    <ds:schemaRef ds:uri="http://schemas.microsoft.com/office/infopath/2007/PartnerControls"/>
-    <ds:schemaRef ds:uri="http://schemas.openxmlformats.org/package/2006/metadata/core-properties"/>
-    <ds:schemaRef ds:uri="http://purl.org/dc/elements/1.1/"/>
-    <ds:schemaRef ds:uri="http://purl.org/dc/terms/"/>
-    <ds:schemaRef ds:uri="http://schemas.microsoft.com/internal/obd"/>
+    <ds:schemaRef ds:uri="http://schemas.microsoft.com/sharepoint/v3/contenttype/forms"/>
   </ds:schemaRefs>
 </ds:datastoreItem>
 </file>
 
 <file path=customXml/itemProps3.xml><?xml version="1.0" encoding="utf-8"?>
-<ds:datastoreItem xmlns:ds="http://schemas.openxmlformats.org/officeDocument/2006/customXml" ds:itemID="{728F1355-E686-4225-B84F-21550D82A764}">
+<ds:datastoreItem xmlns:ds="http://schemas.openxmlformats.org/officeDocument/2006/customXml" ds:itemID="{4981EEB9-8C3F-42F4-B1EC-83A9AA22EC9C}">
   <ds:schemaRefs>
-    <ds:schemaRef ds:uri="http://schemas.microsoft.com/sharepoint/v3/contenttype/forms"/>
+    <ds:schemaRef ds:uri="1066959d-08e3-403d-b5ad-48f659ef38e8"/>
+    <ds:schemaRef ds:uri="a308fb6d-2bca-44a8-b40e-7c117ee46bdd"/>
+    <ds:schemaRef ds:uri="http://purl.org/dc/dcmitype/"/>
+    <ds:schemaRef ds:uri="http://purl.org/dc/elements/1.1/"/>
+    <ds:schemaRef ds:uri="http://purl.org/dc/terms/"/>
+    <ds:schemaRef ds:uri="http://schemas.microsoft.com/office/2006/documentManagement/types"/>
+    <ds:schemaRef ds:uri="http://schemas.microsoft.com/office/2006/metadata/properties"/>
+    <ds:schemaRef ds:uri="http://schemas.microsoft.com/office/infopath/2007/PartnerControls"/>
+    <ds:schemaRef ds:uri="http://schemas.openxmlformats.org/package/2006/metadata/core-properties"/>
+    <ds:schemaRef ds:uri="http://www.w3.org/XML/1998/namespace"/>
   </ds:schemaRefs>
 </ds:datastoreItem>
 </file>
</xml_diff>